<commit_message>
Diagrams: arrows start at the caller (PULL and QUERY reversed)
All diagrams now use one convention: an arrow starts at the side that opens
the connection. For PULL (Prometheus scraping a sidecar) and QUERY (a view
reading a store) the data returns against the arrow.

- Slide 3: Prometheus -> app pods (pull); Kiali -> Prometheus and console ->
  Tempo + Loki (query); legend in the key card.
- Slide 4: metrics row is the real call chain Kiali/Grafana -> Thanos Querier ->
  Prometheus -> Envoy sidecar; query arrows on traces and logs point at the store.
- Slide 11: pull and query arrows reversed; in-process hand-offs (receiver ->
  collector, scrape -> ingest) no longer labelled PUSH; "Ingest + rules" box.
- architecture.md: overview flowchart redrawn caller -> callee, operator/CR
  direction fixed in the scrape sequence, convention explained.

Co-Authored-By: Claude Opus 5.5 (1M context) <noreply@anthropic.com>
</commit_message>
<xml_diff>
--- a/docs/e2e_observability_design.pptx
+++ b/docs/e2e_observability_design.pptx
@@ -849,7 +849,7 @@
           <a:lstStyle/>
           <a:p>
             <a:r>
-              <a:t>Arrows show the direction the data travels; the pill says who opens the connection. Metrics are pulled: Prometheus scrapes every sidecar every 15 s. Traces and logs are pushed over OTLP to the collector, which pushes them on to Tempo and Loki. Views query the stores on demand. Prometheus pushes firing alerts to Alertmanager.</a:t>
+              <a:t>Each arrow starts at the caller, the side that opens the connection; the pill names the mechanism. Metrics are pulled: Prometheus scrapes every sidecar every 15 s. Traces and logs are pushed over OTLP to the collector, which pushes them on to Tempo and Loki. Views query the stores on demand. Prometheus pushes firing alerts to Alertmanager.</a:t>
             </a:r>
           </a:p>
         </p:txBody>
@@ -1707,7 +1707,7 @@
           <a:lstStyle/>
           <a:p>
             <a:r>
-              <a:t>Purple is what exists today. Teal is what Phase 1 adds. Grey systems need no installation; ServiceEntries make them visible as named nodes. Arrows show where the data goes; the pills say who opens the connection: Prometheus pulls metrics, spans and access logs are pushed over OTLP, Kiali and the console query the stores.</a:t>
+              <a:t>Purple is what exists today. Teal is what Phase 1 adds. Grey systems need no installation; ServiceEntries make them visible as named nodes. Arrows show where the data goes; the pills say who opens the connection: Prometheus pulls metrics, spans and access logs are pushed over OTLP, Kiali and the console query the stores. Each arrow starts at the caller.</a:t>
             </a:r>
           </a:p>
         </p:txBody>
@@ -5010,7 +5010,7 @@
           <p:nvPr/>
         </p:nvCxnSpPr>
         <p:spPr>
-          <a:xfrm>
+          <a:xfrm flipH="1">
             <a:off x="2377440" y="2011680"/>
             <a:ext cx="502920" cy="0"/>
           </a:xfrm>
@@ -5104,7 +5104,7 @@
           <p:nvPr/>
         </p:nvCxnSpPr>
         <p:spPr>
-          <a:xfrm>
+          <a:xfrm flipH="1">
             <a:off x="9418320" y="2011680"/>
             <a:ext cx="548640" cy="0"/>
           </a:xfrm>
@@ -5511,7 +5511,7 @@
           <p:nvPr/>
         </p:nvCxnSpPr>
         <p:spPr>
-          <a:xfrm>
+          <a:xfrm flipH="1">
             <a:off x="9418320" y="3246120"/>
             <a:ext cx="548640" cy="0"/>
           </a:xfrm>
@@ -5918,7 +5918,7 @@
           <p:nvPr/>
         </p:nvCxnSpPr>
         <p:spPr>
-          <a:xfrm>
+          <a:xfrm flipH="1">
             <a:off x="9418320" y="4480560"/>
             <a:ext cx="548640" cy="0"/>
           </a:xfrm>
@@ -6058,7 +6058,7 @@
                   <a:schemeClr val="bg1"/>
                 </a:solidFill>
               </a:rPr>
-              <a:t>Rule evaluation</a:t>
+              <a:t>Ingest + rules</a:t>
             </a:r>
           </a:p>
           <a:p>
@@ -6073,7 +6073,7 @@
                   <a:schemeClr val="bg1"/>
                 </a:solidFill>
               </a:rPr>
-              <a:t>Inside Prometheus: 5 alert rules, every 15 s</a:t>
+              <a:t>Writes samples; 5 alert rules every 15 s</a:t>
             </a:r>
           </a:p>
         </p:txBody>
@@ -6289,67 +6289,9 @@
           </a:fontRef>
         </p:style>
       </p:cxnSp>
-      <p:sp>
-        <p:nvSpPr>
-          <p:cNvPr id="35" name="Rounded Rectangle 34"/>
-          <p:cNvSpPr/>
-          <p:nvPr/>
-        </p:nvSpPr>
-        <p:spPr>
-          <a:xfrm>
-            <a:off x="4823460" y="2944368"/>
-            <a:ext cx="457200" cy="237744"/>
-          </a:xfrm>
-          <a:prstGeom prst="roundRect">
-            <a:avLst>
-              <a:gd name="adj" fmla="val 50000"/>
-            </a:avLst>
-          </a:prstGeom>
-          <a:solidFill>
-            <a:schemeClr val="accent1"/>
-          </a:solidFill>
-          <a:ln>
-            <a:noFill/>
-          </a:ln>
-          <a:effectLst/>
-        </p:spPr>
-        <p:style>
-          <a:lnRef idx="1">
-            <a:schemeClr val="accent1"/>
-          </a:lnRef>
-          <a:fillRef idx="3">
-            <a:schemeClr val="accent1"/>
-          </a:fillRef>
-          <a:effectRef idx="2">
-            <a:schemeClr val="accent1"/>
-          </a:effectRef>
-          <a:fontRef idx="minor">
-            <a:schemeClr val="lt1"/>
-          </a:fontRef>
-        </p:style>
-        <p:txBody>
-          <a:bodyPr rtlCol="0" anchor="ctr" wrap="square" lIns="18288" rIns="18288" tIns="10972" bIns="10972"/>
-          <a:lstStyle/>
-          <a:p>
-            <a:pPr algn="ctr">
-              <a:spcAft>
-                <a:spcPts val="400"/>
-              </a:spcAft>
-            </a:pPr>
-            <a:r>
-              <a:rPr sz="800" b="1" i="0">
-                <a:solidFill>
-                  <a:schemeClr val="bg1"/>
-                </a:solidFill>
-              </a:rPr>
-              <a:t>PUSH</a:t>
-            </a:r>
-          </a:p>
-        </p:txBody>
-      </p:sp>
       <p:cxnSp>
         <p:nvCxnSpPr>
-          <p:cNvPr id="36" name="Connector 35"/>
+          <p:cNvPr id="35" name="Connector 34"/>
           <p:cNvCxnSpPr/>
           <p:nvPr/>
         </p:nvCxnSpPr>
@@ -6385,7 +6327,7 @@
       </p:cxnSp>
       <p:sp>
         <p:nvSpPr>
-          <p:cNvPr id="37" name="Rounded Rectangle 36"/>
+          <p:cNvPr id="36" name="Rounded Rectangle 35"/>
           <p:cNvSpPr/>
           <p:nvPr/>
         </p:nvSpPr>
@@ -6443,7 +6385,7 @@
       </p:sp>
       <p:cxnSp>
         <p:nvCxnSpPr>
-          <p:cNvPr id="38" name="Connector 37"/>
+          <p:cNvPr id="37" name="Connector 36"/>
           <p:cNvCxnSpPr/>
           <p:nvPr/>
         </p:nvCxnSpPr>
@@ -6477,67 +6419,9 @@
           </a:fontRef>
         </p:style>
       </p:cxnSp>
-      <p:sp>
-        <p:nvSpPr>
-          <p:cNvPr id="39" name="Rounded Rectangle 38"/>
-          <p:cNvSpPr/>
-          <p:nvPr/>
-        </p:nvSpPr>
-        <p:spPr>
-          <a:xfrm>
-            <a:off x="4823460" y="4178808"/>
-            <a:ext cx="457200" cy="237744"/>
-          </a:xfrm>
-          <a:prstGeom prst="roundRect">
-            <a:avLst>
-              <a:gd name="adj" fmla="val 50000"/>
-            </a:avLst>
-          </a:prstGeom>
-          <a:solidFill>
-            <a:schemeClr val="accent1"/>
-          </a:solidFill>
-          <a:ln>
-            <a:noFill/>
-          </a:ln>
-          <a:effectLst/>
-        </p:spPr>
-        <p:style>
-          <a:lnRef idx="1">
-            <a:schemeClr val="accent1"/>
-          </a:lnRef>
-          <a:fillRef idx="3">
-            <a:schemeClr val="accent1"/>
-          </a:fillRef>
-          <a:effectRef idx="2">
-            <a:schemeClr val="accent1"/>
-          </a:effectRef>
-          <a:fontRef idx="minor">
-            <a:schemeClr val="lt1"/>
-          </a:fontRef>
-        </p:style>
-        <p:txBody>
-          <a:bodyPr rtlCol="0" anchor="ctr" wrap="square" lIns="18288" rIns="18288" tIns="10972" bIns="10972"/>
-          <a:lstStyle/>
-          <a:p>
-            <a:pPr algn="ctr">
-              <a:spcAft>
-                <a:spcPts val="400"/>
-              </a:spcAft>
-            </a:pPr>
-            <a:r>
-              <a:rPr sz="800" b="1" i="0">
-                <a:solidFill>
-                  <a:schemeClr val="bg1"/>
-                </a:solidFill>
-              </a:rPr>
-              <a:t>PUSH</a:t>
-            </a:r>
-          </a:p>
-        </p:txBody>
-      </p:sp>
       <p:cxnSp>
         <p:nvCxnSpPr>
-          <p:cNvPr id="40" name="Connector 39"/>
+          <p:cNvPr id="38" name="Connector 37"/>
           <p:cNvCxnSpPr/>
           <p:nvPr/>
         </p:nvCxnSpPr>
@@ -6573,7 +6457,7 @@
       </p:cxnSp>
       <p:sp>
         <p:nvSpPr>
-          <p:cNvPr id="41" name="Rounded Rectangle 40"/>
+          <p:cNvPr id="39" name="Rounded Rectangle 38"/>
           <p:cNvSpPr/>
           <p:nvPr/>
         </p:nvSpPr>
@@ -6631,7 +6515,7 @@
       </p:sp>
       <p:sp>
         <p:nvSpPr>
-          <p:cNvPr id="42" name="Rounded Rectangle 41"/>
+          <p:cNvPr id="40" name="Rounded Rectangle 39"/>
           <p:cNvSpPr/>
           <p:nvPr/>
         </p:nvSpPr>
@@ -6706,7 +6590,7 @@
       </p:sp>
       <p:sp>
         <p:nvSpPr>
-          <p:cNvPr id="43" name="Rounded Rectangle 42"/>
+          <p:cNvPr id="41" name="Rounded Rectangle 40"/>
           <p:cNvSpPr/>
           <p:nvPr/>
         </p:nvSpPr>
@@ -6781,7 +6665,7 @@
       </p:sp>
       <p:sp>
         <p:nvSpPr>
-          <p:cNvPr id="44" name="Rounded Rectangle 43"/>
+          <p:cNvPr id="42" name="Rounded Rectangle 41"/>
           <p:cNvSpPr/>
           <p:nvPr/>
         </p:nvSpPr>
@@ -6856,7 +6740,7 @@
       </p:sp>
       <p:sp>
         <p:nvSpPr>
-          <p:cNvPr id="45" name="Rounded Rectangle 44"/>
+          <p:cNvPr id="43" name="Rounded Rectangle 42"/>
           <p:cNvSpPr/>
           <p:nvPr/>
         </p:nvSpPr>
@@ -6924,20 +6808,20 @@
                   <a:schemeClr val="tx1"/>
                 </a:solidFill>
               </a:rPr>
-              <a:t>Alerts pushed by the rules</a:t>
-            </a:r>
-          </a:p>
-        </p:txBody>
-      </p:sp>
-      <p:sp>
-        <p:nvSpPr>
-          <p:cNvPr id="46" name="Rounded Rectangle 45"/>
+              <a:t>Receives alerts (PUSH)</a:t>
+            </a:r>
+          </a:p>
+        </p:txBody>
+      </p:sp>
+      <p:sp>
+        <p:nvSpPr>
+          <p:cNvPr id="44" name="Rounded Rectangle 43"/>
           <p:cNvSpPr/>
           <p:nvPr/>
         </p:nvSpPr>
         <p:spPr>
           <a:xfrm>
-            <a:off x="484632" y="5888736"/>
+            <a:off x="484632" y="5797296"/>
             <a:ext cx="457200" cy="237744"/>
           </a:xfrm>
           <a:prstGeom prst="roundRect">
@@ -6989,13 +6873,13 @@
       </p:sp>
       <p:sp>
         <p:nvSpPr>
-          <p:cNvPr id="47" name="TextBox 46"/>
+          <p:cNvPr id="45" name="TextBox 44"/>
           <p:cNvSpPr txBox="1"/>
           <p:nvPr/>
         </p:nvSpPr>
         <p:spPr>
           <a:xfrm>
-            <a:off x="1051560" y="5870448"/>
+            <a:off x="1051560" y="5779008"/>
             <a:ext cx="3017520" cy="274320"/>
           </a:xfrm>
           <a:prstGeom prst="rect">
@@ -7027,13 +6911,13 @@
       </p:sp>
       <p:sp>
         <p:nvSpPr>
-          <p:cNvPr id="48" name="Rounded Rectangle 47"/>
+          <p:cNvPr id="46" name="Rounded Rectangle 45"/>
           <p:cNvSpPr/>
           <p:nvPr/>
         </p:nvSpPr>
         <p:spPr>
           <a:xfrm>
-            <a:off x="4233672" y="5888736"/>
+            <a:off x="4233672" y="5797296"/>
             <a:ext cx="457200" cy="237744"/>
           </a:xfrm>
           <a:prstGeom prst="roundRect">
@@ -7085,13 +6969,13 @@
       </p:sp>
       <p:sp>
         <p:nvSpPr>
-          <p:cNvPr id="49" name="TextBox 48"/>
+          <p:cNvPr id="47" name="TextBox 46"/>
           <p:cNvSpPr txBox="1"/>
           <p:nvPr/>
         </p:nvSpPr>
         <p:spPr>
           <a:xfrm>
-            <a:off x="4800600" y="5870448"/>
+            <a:off x="4800600" y="5779008"/>
             <a:ext cx="3017520" cy="274320"/>
           </a:xfrm>
           <a:prstGeom prst="rect">
@@ -7116,20 +7000,20 @@
                   <a:schemeClr val="tx2"/>
                 </a:solidFill>
               </a:rPr>
-              <a:t>Prometheus opens the connection and scrapes</a:t>
-            </a:r>
-          </a:p>
-        </p:txBody>
-      </p:sp>
-      <p:sp>
-        <p:nvSpPr>
-          <p:cNvPr id="50" name="Rounded Rectangle 49"/>
+              <a:t>Prometheus calls the target, data returns</a:t>
+            </a:r>
+          </a:p>
+        </p:txBody>
+      </p:sp>
+      <p:sp>
+        <p:nvSpPr>
+          <p:cNvPr id="48" name="Rounded Rectangle 47"/>
           <p:cNvSpPr/>
           <p:nvPr/>
         </p:nvSpPr>
         <p:spPr>
           <a:xfrm>
-            <a:off x="7982711" y="5888736"/>
+            <a:off x="7982711" y="5797296"/>
             <a:ext cx="457200" cy="237744"/>
           </a:xfrm>
           <a:prstGeom prst="roundRect">
@@ -7181,13 +7065,13 @@
       </p:sp>
       <p:sp>
         <p:nvSpPr>
-          <p:cNvPr id="51" name="TextBox 50"/>
+          <p:cNvPr id="49" name="TextBox 48"/>
           <p:cNvSpPr txBox="1"/>
           <p:nvPr/>
         </p:nvSpPr>
         <p:spPr>
           <a:xfrm>
-            <a:off x="8549640" y="5870448"/>
+            <a:off x="8549640" y="5779008"/>
             <a:ext cx="3017520" cy="274320"/>
           </a:xfrm>
           <a:prstGeom prst="rect">
@@ -7212,7 +7096,45 @@
                   <a:schemeClr val="tx2"/>
                 </a:solidFill>
               </a:rPr>
-              <a:t>a view asks the store on demand</a:t>
+              <a:t>a view calls the store, results return</a:t>
+            </a:r>
+          </a:p>
+        </p:txBody>
+      </p:sp>
+      <p:sp>
+        <p:nvSpPr>
+          <p:cNvPr id="50" name="TextBox 49"/>
+          <p:cNvSpPr txBox="1"/>
+          <p:nvPr/>
+        </p:nvSpPr>
+        <p:spPr>
+          <a:xfrm>
+            <a:off x="457200" y="6089904"/>
+            <a:ext cx="11247120" cy="256032"/>
+          </a:xfrm>
+          <a:prstGeom prst="rect">
+            <a:avLst/>
+          </a:prstGeom>
+          <a:noFill/>
+        </p:spPr>
+        <p:txBody>
+          <a:bodyPr wrap="square" lIns="0" rIns="0" tIns="0" bIns="0" anchor="t">
+            <a:spAutoFit/>
+          </a:bodyPr>
+          <a:lstStyle/>
+          <a:p>
+            <a:pPr algn="l">
+              <a:spcAft>
+                <a:spcPts val="400"/>
+              </a:spcAft>
+            </a:pPr>
+            <a:r>
+              <a:rPr sz="1050" b="0" i="1">
+                <a:solidFill>
+                  <a:schemeClr val="tx2"/>
+                </a:solidFill>
+              </a:rPr>
+              <a:t>Each arrow starts at the caller. On PULL and QUERY the data travels back against the arrow. Arrows without a pill are hand-offs inside one process.</a:t>
             </a:r>
           </a:p>
         </p:txBody>
@@ -23929,6 +23851,7 @@
               <a:schemeClr val="tx2"/>
             </a:solidFill>
             <a:prstDash val="solid"/>
+            <a:headEnd type="triangle"/>
           </a:ln>
         </p:spPr>
         <p:txBody>
@@ -23973,6 +23896,33 @@
           <a:xfrm>
             <a:off x="3474720" y="2674620"/>
             <a:ext cx="594360" cy="0"/>
+          </a:xfrm>
+          <a:prstGeom prst="line">
+            <a:avLst/>
+          </a:prstGeom>
+          <a:noFill/>
+          <a:ln w="15875">
+            <a:solidFill>
+              <a:schemeClr val="tx2"/>
+            </a:solidFill>
+            <a:prstDash val="solid"/>
+          </a:ln>
+        </p:spPr>
+        <p:txBody>
+          <a:bodyPr/>
+          <a:p/>
+        </p:txBody>
+      </p:sp>
+      <p:sp>
+        <p:nvSpPr>
+          <p:cNvPr id="34" name="Shape 32"/>
+          <p:cNvSpPr/>
+          <p:nvPr/>
+        </p:nvSpPr>
+        <p:spPr>
+          <a:xfrm>
+            <a:off x="5234940" y="4023360"/>
+            <a:ext cx="0" cy="182880"/>
           </a:xfrm>
           <a:prstGeom prst="line">
             <a:avLst/>
@@ -23993,14 +23943,178 @@
       </p:sp>
       <p:sp>
         <p:nvSpPr>
-          <p:cNvPr id="34" name="Shape 32"/>
+          <p:cNvPr id="35" name="Shape 33"/>
           <p:cNvSpPr/>
           <p:nvPr/>
         </p:nvSpPr>
         <p:spPr>
           <a:xfrm>
-            <a:off x="5234940" y="4023360"/>
-            <a:ext cx="0" cy="182880"/>
+            <a:off x="6400800" y="2674620"/>
+            <a:ext cx="274320" cy="0"/>
+          </a:xfrm>
+          <a:prstGeom prst="line">
+            <a:avLst/>
+          </a:prstGeom>
+          <a:noFill/>
+          <a:ln w="15875">
+            <a:solidFill>
+              <a:schemeClr val="tx2"/>
+            </a:solidFill>
+            <a:prstDash val="solid"/>
+            <a:headEnd type="triangle"/>
+          </a:ln>
+        </p:spPr>
+        <p:txBody>
+          <a:bodyPr/>
+          <a:p/>
+        </p:txBody>
+      </p:sp>
+      <p:sp>
+        <p:nvSpPr>
+          <p:cNvPr id="36" name="Shape 34"/>
+          <p:cNvSpPr/>
+          <p:nvPr/>
+        </p:nvSpPr>
+        <p:spPr>
+          <a:xfrm>
+            <a:off x="6675120" y="2674620"/>
+            <a:ext cx="0" cy="411480"/>
+          </a:xfrm>
+          <a:prstGeom prst="line">
+            <a:avLst/>
+          </a:prstGeom>
+          <a:noFill/>
+          <a:ln w="15875">
+            <a:solidFill>
+              <a:schemeClr val="tx2"/>
+            </a:solidFill>
+            <a:prstDash val="solid"/>
+          </a:ln>
+        </p:spPr>
+        <p:txBody>
+          <a:bodyPr/>
+          <a:p/>
+        </p:txBody>
+      </p:sp>
+      <p:sp>
+        <p:nvSpPr>
+          <p:cNvPr id="37" name="Shape 35"/>
+          <p:cNvSpPr/>
+          <p:nvPr/>
+        </p:nvSpPr>
+        <p:spPr>
+          <a:xfrm>
+            <a:off x="6675120" y="3086100"/>
+            <a:ext cx="320040" cy="0"/>
+          </a:xfrm>
+          <a:prstGeom prst="line">
+            <a:avLst/>
+          </a:prstGeom>
+          <a:noFill/>
+          <a:ln w="15875">
+            <a:solidFill>
+              <a:schemeClr val="tx2"/>
+            </a:solidFill>
+            <a:prstDash val="solid"/>
+          </a:ln>
+        </p:spPr>
+        <p:txBody>
+          <a:bodyPr/>
+          <a:p/>
+        </p:txBody>
+      </p:sp>
+      <p:sp>
+        <p:nvSpPr>
+          <p:cNvPr id="38" name="Shape 36"/>
+          <p:cNvSpPr/>
+          <p:nvPr/>
+        </p:nvSpPr>
+        <p:spPr>
+          <a:xfrm>
+            <a:off x="6400800" y="4594860"/>
+            <a:ext cx="274320" cy="0"/>
+          </a:xfrm>
+          <a:prstGeom prst="line">
+            <a:avLst/>
+          </a:prstGeom>
+          <a:noFill/>
+          <a:ln w="15875">
+            <a:solidFill>
+              <a:schemeClr val="tx2"/>
+            </a:solidFill>
+            <a:prstDash val="solid"/>
+            <a:headEnd type="triangle"/>
+          </a:ln>
+        </p:spPr>
+        <p:txBody>
+          <a:bodyPr/>
+          <a:p/>
+        </p:txBody>
+      </p:sp>
+      <p:sp>
+        <p:nvSpPr>
+          <p:cNvPr id="39" name="Shape 37"/>
+          <p:cNvSpPr/>
+          <p:nvPr/>
+        </p:nvSpPr>
+        <p:spPr>
+          <a:xfrm>
+            <a:off x="6675120" y="4137660"/>
+            <a:ext cx="0" cy="457200"/>
+          </a:xfrm>
+          <a:prstGeom prst="line">
+            <a:avLst/>
+          </a:prstGeom>
+          <a:noFill/>
+          <a:ln w="15875">
+            <a:solidFill>
+              <a:schemeClr val="tx2"/>
+            </a:solidFill>
+            <a:prstDash val="solid"/>
+          </a:ln>
+        </p:spPr>
+        <p:txBody>
+          <a:bodyPr/>
+          <a:p/>
+        </p:txBody>
+      </p:sp>
+      <p:sp>
+        <p:nvSpPr>
+          <p:cNvPr id="40" name="Shape 38"/>
+          <p:cNvSpPr/>
+          <p:nvPr/>
+        </p:nvSpPr>
+        <p:spPr>
+          <a:xfrm>
+            <a:off x="6675120" y="4137660"/>
+            <a:ext cx="320040" cy="0"/>
+          </a:xfrm>
+          <a:prstGeom prst="line">
+            <a:avLst/>
+          </a:prstGeom>
+          <a:noFill/>
+          <a:ln w="15875">
+            <a:solidFill>
+              <a:schemeClr val="tx2"/>
+            </a:solidFill>
+            <a:prstDash val="solid"/>
+          </a:ln>
+        </p:spPr>
+        <p:txBody>
+          <a:bodyPr/>
+          <a:p/>
+        </p:txBody>
+      </p:sp>
+      <p:sp>
+        <p:nvSpPr>
+          <p:cNvPr id="41" name="Shape 39"/>
+          <p:cNvSpPr/>
+          <p:nvPr/>
+        </p:nvSpPr>
+        <p:spPr>
+          <a:xfrm>
+            <a:off x="1463040" y="4983480"/>
+            <a:ext cx="0" cy="640080"/>
           </a:xfrm>
           <a:prstGeom prst="line">
             <a:avLst/>
@@ -24021,14 +24135,14 @@
       </p:sp>
       <p:sp>
         <p:nvSpPr>
-          <p:cNvPr id="35" name="Shape 33"/>
+          <p:cNvPr id="42" name="Shape 40"/>
           <p:cNvSpPr/>
           <p:nvPr/>
         </p:nvSpPr>
         <p:spPr>
           <a:xfrm>
-            <a:off x="6400800" y="2674620"/>
-            <a:ext cx="274320" cy="0"/>
+            <a:off x="2743200" y="4983480"/>
+            <a:ext cx="0" cy="457200"/>
           </a:xfrm>
           <a:prstGeom prst="line">
             <a:avLst/>
@@ -24048,14 +24162,14 @@
       </p:sp>
       <p:sp>
         <p:nvSpPr>
-          <p:cNvPr id="36" name="Shape 34"/>
+          <p:cNvPr id="43" name="Shape 41"/>
           <p:cNvSpPr/>
           <p:nvPr/>
         </p:nvSpPr>
         <p:spPr>
           <a:xfrm>
-            <a:off x="6675120" y="2674620"/>
-            <a:ext cx="0" cy="411480"/>
+            <a:off x="2743200" y="5440680"/>
+            <a:ext cx="2491739" cy="0"/>
           </a:xfrm>
           <a:prstGeom prst="line">
             <a:avLst/>
@@ -24075,14 +24189,14 @@
       </p:sp>
       <p:sp>
         <p:nvSpPr>
-          <p:cNvPr id="37" name="Shape 35"/>
+          <p:cNvPr id="44" name="Shape 42"/>
           <p:cNvSpPr/>
           <p:nvPr/>
         </p:nvSpPr>
         <p:spPr>
           <a:xfrm>
-            <a:off x="6675120" y="3086100"/>
-            <a:ext cx="320040" cy="0"/>
+            <a:off x="5234940" y="5440680"/>
+            <a:ext cx="0" cy="182880"/>
           </a:xfrm>
           <a:prstGeom prst="line">
             <a:avLst/>
@@ -24103,198 +24217,6 @@
       </p:sp>
       <p:sp>
         <p:nvSpPr>
-          <p:cNvPr id="38" name="Shape 36"/>
-          <p:cNvSpPr/>
-          <p:nvPr/>
-        </p:nvSpPr>
-        <p:spPr>
-          <a:xfrm>
-            <a:off x="6400800" y="4594860"/>
-            <a:ext cx="274320" cy="0"/>
-          </a:xfrm>
-          <a:prstGeom prst="line">
-            <a:avLst/>
-          </a:prstGeom>
-          <a:noFill/>
-          <a:ln w="15875">
-            <a:solidFill>
-              <a:schemeClr val="tx2"/>
-            </a:solidFill>
-            <a:prstDash val="solid"/>
-          </a:ln>
-        </p:spPr>
-        <p:txBody>
-          <a:bodyPr/>
-          <a:p/>
-        </p:txBody>
-      </p:sp>
-      <p:sp>
-        <p:nvSpPr>
-          <p:cNvPr id="39" name="Shape 37"/>
-          <p:cNvSpPr/>
-          <p:nvPr/>
-        </p:nvSpPr>
-        <p:spPr>
-          <a:xfrm>
-            <a:off x="6675120" y="4137660"/>
-            <a:ext cx="0" cy="457200"/>
-          </a:xfrm>
-          <a:prstGeom prst="line">
-            <a:avLst/>
-          </a:prstGeom>
-          <a:noFill/>
-          <a:ln w="15875">
-            <a:solidFill>
-              <a:schemeClr val="tx2"/>
-            </a:solidFill>
-            <a:prstDash val="solid"/>
-          </a:ln>
-        </p:spPr>
-        <p:txBody>
-          <a:bodyPr/>
-          <a:p/>
-        </p:txBody>
-      </p:sp>
-      <p:sp>
-        <p:nvSpPr>
-          <p:cNvPr id="40" name="Shape 38"/>
-          <p:cNvSpPr/>
-          <p:nvPr/>
-        </p:nvSpPr>
-        <p:spPr>
-          <a:xfrm>
-            <a:off x="6675120" y="4137660"/>
-            <a:ext cx="320040" cy="0"/>
-          </a:xfrm>
-          <a:prstGeom prst="line">
-            <a:avLst/>
-          </a:prstGeom>
-          <a:noFill/>
-          <a:ln w="15875">
-            <a:solidFill>
-              <a:schemeClr val="tx2"/>
-            </a:solidFill>
-            <a:prstDash val="solid"/>
-            <a:tailEnd type="triangle"/>
-          </a:ln>
-        </p:spPr>
-        <p:txBody>
-          <a:bodyPr/>
-          <a:p/>
-        </p:txBody>
-      </p:sp>
-      <p:sp>
-        <p:nvSpPr>
-          <p:cNvPr id="41" name="Shape 39"/>
-          <p:cNvSpPr/>
-          <p:nvPr/>
-        </p:nvSpPr>
-        <p:spPr>
-          <a:xfrm>
-            <a:off x="1463040" y="4983480"/>
-            <a:ext cx="0" cy="640080"/>
-          </a:xfrm>
-          <a:prstGeom prst="line">
-            <a:avLst/>
-          </a:prstGeom>
-          <a:noFill/>
-          <a:ln w="15875">
-            <a:solidFill>
-              <a:schemeClr val="tx2"/>
-            </a:solidFill>
-            <a:prstDash val="solid"/>
-            <a:tailEnd type="triangle"/>
-          </a:ln>
-        </p:spPr>
-        <p:txBody>
-          <a:bodyPr/>
-          <a:p/>
-        </p:txBody>
-      </p:sp>
-      <p:sp>
-        <p:nvSpPr>
-          <p:cNvPr id="42" name="Shape 40"/>
-          <p:cNvSpPr/>
-          <p:nvPr/>
-        </p:nvSpPr>
-        <p:spPr>
-          <a:xfrm>
-            <a:off x="2743200" y="4983480"/>
-            <a:ext cx="0" cy="457200"/>
-          </a:xfrm>
-          <a:prstGeom prst="line">
-            <a:avLst/>
-          </a:prstGeom>
-          <a:noFill/>
-          <a:ln w="15875">
-            <a:solidFill>
-              <a:schemeClr val="tx2"/>
-            </a:solidFill>
-            <a:prstDash val="solid"/>
-          </a:ln>
-        </p:spPr>
-        <p:txBody>
-          <a:bodyPr/>
-          <a:p/>
-        </p:txBody>
-      </p:sp>
-      <p:sp>
-        <p:nvSpPr>
-          <p:cNvPr id="43" name="Shape 41"/>
-          <p:cNvSpPr/>
-          <p:nvPr/>
-        </p:nvSpPr>
-        <p:spPr>
-          <a:xfrm>
-            <a:off x="2743200" y="5440680"/>
-            <a:ext cx="2491739" cy="0"/>
-          </a:xfrm>
-          <a:prstGeom prst="line">
-            <a:avLst/>
-          </a:prstGeom>
-          <a:noFill/>
-          <a:ln w="15875">
-            <a:solidFill>
-              <a:schemeClr val="tx2"/>
-            </a:solidFill>
-            <a:prstDash val="solid"/>
-          </a:ln>
-        </p:spPr>
-        <p:txBody>
-          <a:bodyPr/>
-          <a:p/>
-        </p:txBody>
-      </p:sp>
-      <p:sp>
-        <p:nvSpPr>
-          <p:cNvPr id="44" name="Shape 42"/>
-          <p:cNvSpPr/>
-          <p:nvPr/>
-        </p:nvSpPr>
-        <p:spPr>
-          <a:xfrm>
-            <a:off x="5234940" y="5440680"/>
-            <a:ext cx="0" cy="182880"/>
-          </a:xfrm>
-          <a:prstGeom prst="line">
-            <a:avLst/>
-          </a:prstGeom>
-          <a:noFill/>
-          <a:ln w="15875">
-            <a:solidFill>
-              <a:schemeClr val="tx2"/>
-            </a:solidFill>
-            <a:prstDash val="solid"/>
-            <a:tailEnd type="triangle"/>
-          </a:ln>
-        </p:spPr>
-        <p:txBody>
-          <a:bodyPr/>
-          <a:p/>
-        </p:txBody>
-      </p:sp>
-      <p:sp>
-        <p:nvSpPr>
           <p:cNvPr id="45" name="Key card"/>
           <p:cNvSpPr/>
           <p:nvPr/>
@@ -24302,7 +24224,7 @@
         <p:spPr>
           <a:xfrm>
             <a:off x="9326880" y="1828800"/>
-            <a:ext cx="2377440" cy="3520440"/>
+            <a:ext cx="2377440" cy="3886200"/>
           </a:xfrm>
           <a:prstGeom prst="roundRect">
             <a:avLst>
@@ -24973,13 +24895,47 @@
       </p:sp>
       <p:sp>
         <p:nvSpPr>
-          <p:cNvPr id="61" name="Rounded Rectangle 60"/>
+          <p:cNvPr id="61" name="TextBox 60"/>
+          <p:cNvSpPr txBox="1"/>
+          <p:nvPr/>
+        </p:nvSpPr>
+        <p:spPr>
+          <a:xfrm>
+            <a:off x="9555480" y="4690872"/>
+            <a:ext cx="2103120" cy="201168"/>
+          </a:xfrm>
+          <a:prstGeom prst="rect">
+            <a:avLst/>
+          </a:prstGeom>
+          <a:noFill/>
+        </p:spPr>
+        <p:txBody>
+          <a:bodyPr wrap="square" lIns="0" rIns="0" tIns="0" bIns="0">
+            <a:spAutoFit/>
+          </a:bodyPr>
+          <a:lstStyle/>
+          <a:p>
+            <a:pPr algn="l"/>
+            <a:r>
+              <a:rPr sz="950" i="1">
+                <a:solidFill>
+                  <a:schemeClr val="tx2"/>
+                </a:solidFill>
+              </a:rPr>
+              <a:t>Arrow = caller to callee</a:t>
+            </a:r>
+          </a:p>
+        </p:txBody>
+      </p:sp>
+      <p:sp>
+        <p:nvSpPr>
+          <p:cNvPr id="62" name="Rounded Rectangle 61"/>
           <p:cNvSpPr/>
           <p:nvPr/>
         </p:nvSpPr>
         <p:spPr>
           <a:xfrm>
-            <a:off x="9555480" y="4654296"/>
+            <a:off x="9555480" y="4928616"/>
             <a:ext cx="475488" cy="237744"/>
           </a:xfrm>
           <a:prstGeom prst="roundRect">
@@ -25027,13 +24983,13 @@
       </p:sp>
       <p:sp>
         <p:nvSpPr>
-          <p:cNvPr id="62" name="TextBox 61"/>
+          <p:cNvPr id="63" name="TextBox 62"/>
           <p:cNvSpPr txBox="1"/>
           <p:nvPr/>
         </p:nvSpPr>
         <p:spPr>
           <a:xfrm>
-            <a:off x="10104120" y="4681728"/>
+            <a:off x="10104120" y="4956048"/>
             <a:ext cx="1554480" cy="201168"/>
           </a:xfrm>
           <a:prstGeom prst="rect">
@@ -25061,13 +25017,13 @@
       </p:sp>
       <p:sp>
         <p:nvSpPr>
-          <p:cNvPr id="63" name="Rounded Rectangle 62"/>
+          <p:cNvPr id="64" name="Rounded Rectangle 63"/>
           <p:cNvSpPr/>
           <p:nvPr/>
         </p:nvSpPr>
         <p:spPr>
           <a:xfrm>
-            <a:off x="9555480" y="4873752"/>
+            <a:off x="9555480" y="5157216"/>
             <a:ext cx="475488" cy="237744"/>
           </a:xfrm>
           <a:prstGeom prst="roundRect">
@@ -25115,13 +25071,13 @@
       </p:sp>
       <p:sp>
         <p:nvSpPr>
-          <p:cNvPr id="64" name="TextBox 63"/>
+          <p:cNvPr id="65" name="TextBox 64"/>
           <p:cNvSpPr txBox="1"/>
           <p:nvPr/>
         </p:nvSpPr>
         <p:spPr>
           <a:xfrm>
-            <a:off x="10104120" y="4901184"/>
+            <a:off x="10104120" y="5184648"/>
             <a:ext cx="1554480" cy="201168"/>
           </a:xfrm>
           <a:prstGeom prst="rect">
@@ -25142,20 +25098,20 @@
                   <a:schemeClr val="tx2"/>
                 </a:solidFill>
               </a:rPr>
-              <a:t>Prometheus scrapes</a:t>
-            </a:r>
-          </a:p>
-        </p:txBody>
-      </p:sp>
-      <p:sp>
-        <p:nvSpPr>
-          <p:cNvPr id="65" name="Rounded Rectangle 64"/>
+              <a:t>Prometheus calls the pod</a:t>
+            </a:r>
+          </a:p>
+        </p:txBody>
+      </p:sp>
+      <p:sp>
+        <p:nvSpPr>
+          <p:cNvPr id="66" name="Rounded Rectangle 65"/>
           <p:cNvSpPr/>
           <p:nvPr/>
         </p:nvSpPr>
         <p:spPr>
           <a:xfrm>
-            <a:off x="9555480" y="5093207"/>
+            <a:off x="9555480" y="5385816"/>
             <a:ext cx="475488" cy="237744"/>
           </a:xfrm>
           <a:prstGeom prst="roundRect">
@@ -25203,13 +25159,13 @@
       </p:sp>
       <p:sp>
         <p:nvSpPr>
-          <p:cNvPr id="66" name="TextBox 65"/>
+          <p:cNvPr id="67" name="TextBox 66"/>
           <p:cNvSpPr txBox="1"/>
           <p:nvPr/>
         </p:nvSpPr>
         <p:spPr>
           <a:xfrm>
-            <a:off x="10104120" y="5120640"/>
+            <a:off x="10104120" y="5413248"/>
             <a:ext cx="1554480" cy="201168"/>
           </a:xfrm>
           <a:prstGeom prst="rect">
@@ -25230,7 +25186,7 @@
                   <a:schemeClr val="tx2"/>
                 </a:solidFill>
               </a:rPr>
-              <a:t>view reads the store</a:t>
+              <a:t>view calls the store</a:t>
             </a:r>
           </a:p>
         </p:txBody>
@@ -25464,7 +25420,7 @@
               <a:schemeClr val="tx2"/>
             </a:solidFill>
             <a:prstDash val="solid"/>
-            <a:tailEnd type="triangle"/>
+            <a:headEnd type="triangle"/>
           </a:ln>
         </p:spPr>
         <p:txBody>
@@ -25533,7 +25489,7 @@
                   <a:schemeClr val="bg1"/>
                 </a:solidFill>
               </a:rPr>
-              <a:t>PodMonitor</a:t>
+              <a:t>Prometheus (UWM)</a:t>
             </a:r>
             <a:endParaRPr lang="en-US" sz="1400" dirty="0"/>
           </a:p>
@@ -25547,7 +25503,7 @@
                   <a:schemeClr val="accent6"/>
                 </a:solidFill>
               </a:rPr>
-              <a:t>Per mesh namespace</a:t>
+              <a:t>Targets from PodMonitor</a:t>
             </a:r>
             <a:endParaRPr lang="en-US" sz="1400" dirty="0"/>
           </a:p>
@@ -25573,7 +25529,7 @@
               <a:schemeClr val="tx2"/>
             </a:solidFill>
             <a:prstDash val="solid"/>
-            <a:tailEnd type="triangle"/>
+            <a:headEnd type="triangle"/>
           </a:ln>
         </p:spPr>
         <p:txBody>
@@ -25642,7 +25598,7 @@
                   <a:schemeClr val="bg1"/>
                 </a:solidFill>
               </a:rPr>
-              <a:t>Prometheus (UWM)</a:t>
+              <a:t>Thanos Querier</a:t>
             </a:r>
             <a:endParaRPr lang="en-US" sz="1400" dirty="0"/>
           </a:p>
@@ -25656,7 +25612,7 @@
                   <a:schemeClr val="accent6"/>
                 </a:solidFill>
               </a:rPr>
-              <a:t>Cluster monitoring</a:t>
+              <a:t>Query front for UWM</a:t>
             </a:r>
             <a:endParaRPr lang="en-US" sz="1400" dirty="0"/>
           </a:p>
@@ -25682,7 +25638,7 @@
               <a:schemeClr val="tx2"/>
             </a:solidFill>
             <a:prstDash val="solid"/>
-            <a:tailEnd type="triangle"/>
+            <a:headEnd type="triangle"/>
           </a:ln>
         </p:spPr>
         <p:txBody>
@@ -25751,7 +25707,7 @@
                   <a:schemeClr val="tx1"/>
                 </a:solidFill>
               </a:rPr>
-              <a:t>Kiali + alerts</a:t>
+              <a:t>Kiali + Grafana</a:t>
             </a:r>
             <a:endParaRPr lang="en-US" sz="1400" dirty="0"/>
           </a:p>
@@ -26191,7 +26147,7 @@
               <a:schemeClr val="tx2"/>
             </a:solidFill>
             <a:prstDash val="solid"/>
-            <a:tailEnd type="triangle"/>
+            <a:headEnd type="triangle"/>
           </a:ln>
         </p:spPr>
         <p:txBody>
@@ -26444,7 +26400,7 @@
                   <a:schemeClr val="tx2"/>
                 </a:solidFill>
               </a:rPr>
-              <a:t>scraped :15020</a:t>
+              <a:t>scrapes :15020</a:t>
             </a:r>
           </a:p>
         </p:txBody>
@@ -26458,94 +26414,6 @@
         <p:spPr>
           <a:xfrm>
             <a:off x="5797296" y="1842515"/>
-            <a:ext cx="566928" cy="237744"/>
-          </a:xfrm>
-          <a:prstGeom prst="roundRect">
-            <a:avLst>
-              <a:gd name="adj" fmla="val 50000"/>
-            </a:avLst>
-          </a:prstGeom>
-          <a:solidFill>
-            <a:schemeClr val="accent2"/>
-          </a:solidFill>
-          <a:ln>
-            <a:noFill/>
-          </a:ln>
-          <a:effectLst/>
-        </p:spPr>
-        <p:style>
-          <a:lnRef idx="1">
-            <a:schemeClr val="accent1"/>
-          </a:lnRef>
-          <a:fillRef idx="3">
-            <a:schemeClr val="accent1"/>
-          </a:fillRef>
-          <a:effectRef idx="2">
-            <a:schemeClr val="accent1"/>
-          </a:effectRef>
-          <a:fontRef idx="minor">
-            <a:schemeClr val="lt1"/>
-          </a:fontRef>
-        </p:style>
-        <p:txBody>
-          <a:bodyPr rtlCol="0" anchor="ctr" lIns="0" rIns="0" tIns="0" bIns="0"/>
-          <a:lstStyle/>
-          <a:p>
-            <a:pPr algn="ctr"/>
-            <a:r>
-              <a:rPr sz="850" b="1">
-                <a:solidFill>
-                  <a:schemeClr val="bg1"/>
-                </a:solidFill>
-              </a:rPr>
-              <a:t>PULL</a:t>
-            </a:r>
-          </a:p>
-        </p:txBody>
-      </p:sp>
-      <p:sp>
-        <p:nvSpPr>
-          <p:cNvPr id="34" name="TextBox 33"/>
-          <p:cNvSpPr txBox="1"/>
-          <p:nvPr/>
-        </p:nvSpPr>
-        <p:spPr>
-          <a:xfrm>
-            <a:off x="5657088" y="2208275"/>
-            <a:ext cx="847344" cy="292608"/>
-          </a:xfrm>
-          <a:prstGeom prst="rect">
-            <a:avLst/>
-          </a:prstGeom>
-          <a:noFill/>
-        </p:spPr>
-        <p:txBody>
-          <a:bodyPr wrap="square" lIns="0" rIns="0" tIns="0" bIns="0">
-            <a:spAutoFit/>
-          </a:bodyPr>
-          <a:lstStyle/>
-          <a:p>
-            <a:pPr algn="ctr"/>
-            <a:r>
-              <a:rPr sz="850" i="0">
-                <a:solidFill>
-                  <a:schemeClr val="tx2"/>
-                </a:solidFill>
-              </a:rPr>
-              <a:t>targets for scrape</a:t>
-            </a:r>
-          </a:p>
-        </p:txBody>
-      </p:sp>
-      <p:sp>
-        <p:nvSpPr>
-          <p:cNvPr id="35" name="Rounded Rectangle 34"/>
-          <p:cNvSpPr/>
-          <p:nvPr/>
-        </p:nvSpPr>
-        <p:spPr>
-          <a:xfrm>
-            <a:off x="8830056" y="1842515"/>
             <a:ext cx="566928" cy="237744"/>
           </a:xfrm>
           <a:prstGeom prst="roundRect">
@@ -26593,13 +26461,13 @@
       </p:sp>
       <p:sp>
         <p:nvSpPr>
-          <p:cNvPr id="36" name="TextBox 35"/>
+          <p:cNvPr id="34" name="TextBox 33"/>
           <p:cNvSpPr txBox="1"/>
           <p:nvPr/>
         </p:nvSpPr>
         <p:spPr>
           <a:xfrm>
-            <a:off x="8689848" y="2208275"/>
+            <a:off x="5657088" y="2208275"/>
             <a:ext cx="847344" cy="292608"/>
           </a:xfrm>
           <a:prstGeom prst="rect">
@@ -26620,7 +26488,95 @@
                   <a:schemeClr val="tx2"/>
                 </a:solidFill>
               </a:rPr>
-              <a:t>PromQL</a:t>
+              <a:t>fans out</a:t>
+            </a:r>
+          </a:p>
+        </p:txBody>
+      </p:sp>
+      <p:sp>
+        <p:nvSpPr>
+          <p:cNvPr id="35" name="Rounded Rectangle 34"/>
+          <p:cNvSpPr/>
+          <p:nvPr/>
+        </p:nvSpPr>
+        <p:spPr>
+          <a:xfrm>
+            <a:off x="8830056" y="1842515"/>
+            <a:ext cx="566928" cy="237744"/>
+          </a:xfrm>
+          <a:prstGeom prst="roundRect">
+            <a:avLst>
+              <a:gd name="adj" fmla="val 50000"/>
+            </a:avLst>
+          </a:prstGeom>
+          <a:solidFill>
+            <a:schemeClr val="accent5"/>
+          </a:solidFill>
+          <a:ln>
+            <a:noFill/>
+          </a:ln>
+          <a:effectLst/>
+        </p:spPr>
+        <p:style>
+          <a:lnRef idx="1">
+            <a:schemeClr val="accent1"/>
+          </a:lnRef>
+          <a:fillRef idx="3">
+            <a:schemeClr val="accent1"/>
+          </a:fillRef>
+          <a:effectRef idx="2">
+            <a:schemeClr val="accent1"/>
+          </a:effectRef>
+          <a:fontRef idx="minor">
+            <a:schemeClr val="lt1"/>
+          </a:fontRef>
+        </p:style>
+        <p:txBody>
+          <a:bodyPr rtlCol="0" anchor="ctr" lIns="0" rIns="0" tIns="0" bIns="0"/>
+          <a:lstStyle/>
+          <a:p>
+            <a:pPr algn="ctr"/>
+            <a:r>
+              <a:rPr sz="850" b="1">
+                <a:solidFill>
+                  <a:schemeClr val="bg1"/>
+                </a:solidFill>
+              </a:rPr>
+              <a:t>QUERY</a:t>
+            </a:r>
+          </a:p>
+        </p:txBody>
+      </p:sp>
+      <p:sp>
+        <p:nvSpPr>
+          <p:cNvPr id="36" name="TextBox 35"/>
+          <p:cNvSpPr txBox="1"/>
+          <p:nvPr/>
+        </p:nvSpPr>
+        <p:spPr>
+          <a:xfrm>
+            <a:off x="8689848" y="2208275"/>
+            <a:ext cx="847344" cy="292608"/>
+          </a:xfrm>
+          <a:prstGeom prst="rect">
+            <a:avLst/>
+          </a:prstGeom>
+          <a:noFill/>
+        </p:spPr>
+        <p:txBody>
+          <a:bodyPr wrap="square" lIns="0" rIns="0" tIns="0" bIns="0">
+            <a:spAutoFit/>
+          </a:bodyPr>
+          <a:lstStyle/>
+          <a:p>
+            <a:pPr algn="ctr"/>
+            <a:r>
+              <a:rPr sz="850" i="0">
+                <a:solidFill>
+                  <a:schemeClr val="tx2"/>
+                </a:solidFill>
+              </a:rPr>
+              <a:t>PromQL :9091</a:t>
             </a:r>
           </a:p>
         </p:txBody>
@@ -27066,7 +27022,7 @@
               <a:schemeClr val="tx2"/>
             </a:solidFill>
             <a:prstDash val="solid"/>
-            <a:tailEnd type="triangle"/>
+            <a:headEnd type="triangle"/>
           </a:ln>
         </p:spPr>
         <p:txBody>
@@ -27664,7 +27620,41 @@
       </p:sp>
       <p:sp>
         <p:nvSpPr>
-          <p:cNvPr id="63" name="Rounded Rectangle 62"/>
+          <p:cNvPr id="63" name="TextBox 62"/>
+          <p:cNvSpPr txBox="1"/>
+          <p:nvPr/>
+        </p:nvSpPr>
+        <p:spPr>
+          <a:xfrm>
+            <a:off x="2240280" y="1243584"/>
+            <a:ext cx="1600200" cy="228600"/>
+          </a:xfrm>
+          <a:prstGeom prst="rect">
+            <a:avLst/>
+          </a:prstGeom>
+          <a:noFill/>
+        </p:spPr>
+        <p:txBody>
+          <a:bodyPr wrap="square" lIns="0" rIns="0" tIns="0" bIns="0">
+            <a:spAutoFit/>
+          </a:bodyPr>
+          <a:lstStyle/>
+          <a:p>
+            <a:pPr algn="l"/>
+            <a:r>
+              <a:rPr sz="1000" i="1">
+                <a:solidFill>
+                  <a:schemeClr val="tx2"/>
+                </a:solidFill>
+              </a:rPr>
+              <a:t>Arrow = caller to callee</a:t>
+            </a:r>
+          </a:p>
+        </p:txBody>
+      </p:sp>
+      <p:sp>
+        <p:nvSpPr>
+          <p:cNvPr id="64" name="Rounded Rectangle 63"/>
           <p:cNvSpPr/>
           <p:nvPr/>
         </p:nvSpPr>
@@ -27718,7 +27708,7 @@
       </p:sp>
       <p:sp>
         <p:nvSpPr>
-          <p:cNvPr id="64" name="TextBox 63"/>
+          <p:cNvPr id="65" name="TextBox 64"/>
           <p:cNvSpPr txBox="1"/>
           <p:nvPr/>
         </p:nvSpPr>
@@ -27745,14 +27735,14 @@
                   <a:schemeClr val="tx2"/>
                 </a:solidFill>
               </a:rPr>
-              <a:t>sender opens the connection</a:t>
-            </a:r>
-          </a:p>
-        </p:txBody>
-      </p:sp>
-      <p:sp>
-        <p:nvSpPr>
-          <p:cNvPr id="65" name="Rounded Rectangle 64"/>
+              <a:t>sender sends the data</a:t>
+            </a:r>
+          </a:p>
+        </p:txBody>
+      </p:sp>
+      <p:sp>
+        <p:nvSpPr>
+          <p:cNvPr id="66" name="Rounded Rectangle 65"/>
           <p:cNvSpPr/>
           <p:nvPr/>
         </p:nvSpPr>
@@ -27806,7 +27796,7 @@
       </p:sp>
       <p:sp>
         <p:nvSpPr>
-          <p:cNvPr id="66" name="TextBox 65"/>
+          <p:cNvPr id="67" name="TextBox 66"/>
           <p:cNvSpPr txBox="1"/>
           <p:nvPr/>
         </p:nvSpPr>
@@ -27833,14 +27823,14 @@
                   <a:schemeClr val="tx2"/>
                 </a:solidFill>
               </a:rPr>
-              <a:t>Prometheus scrapes the target</a:t>
-            </a:r>
-          </a:p>
-        </p:txBody>
-      </p:sp>
-      <p:sp>
-        <p:nvSpPr>
-          <p:cNvPr id="67" name="Rounded Rectangle 66"/>
+              <a:t>Prometheus calls, data returns</a:t>
+            </a:r>
+          </a:p>
+        </p:txBody>
+      </p:sp>
+      <p:sp>
+        <p:nvSpPr>
+          <p:cNvPr id="68" name="Rounded Rectangle 67"/>
           <p:cNvSpPr/>
           <p:nvPr/>
         </p:nvSpPr>
@@ -27894,7 +27884,7 @@
       </p:sp>
       <p:sp>
         <p:nvSpPr>
-          <p:cNvPr id="68" name="TextBox 67"/>
+          <p:cNvPr id="69" name="TextBox 68"/>
           <p:cNvSpPr txBox="1"/>
           <p:nvPr/>
         </p:nvSpPr>
@@ -27921,7 +27911,7 @@
                   <a:schemeClr val="tx2"/>
                 </a:solidFill>
               </a:rPr>
-              <a:t>view asks the store</a:t>
+              <a:t>view calls, results return</a:t>
             </a:r>
           </a:p>
         </p:txBody>

</xml_diff>

<commit_message>
Deck and docs: how to add the mobile banking app (Phase 2)
- New slide 24 before "Implementation steps": start the trace at the tap.
  Request path (app with the OTel SDK -> edge forwarding traceparent -> Route ->
  Istio gateway continuing the trace -> services) and telemetry path (app pushes
  its spans to a public OTLP endpoint -> edge collector with redaction and
  sampling -> internal collector -> stores), plus gains, what to build,
  guardrails and decisions.
- architecture.md section 19 with the same design and a diagram.

Co-Authored-By: Claude Opus 5.5 (1M context) <noreply@anthropic.com>
</commit_message>
<xml_diff>
--- a/docs/e2e_observability_design.pptx
+++ b/docs/e2e_observability_design.pptx
@@ -28,6 +28,7 @@
     <p:sldId id="278" r:id="rId29"/>
     <p:sldId id="279" r:id="rId30"/>
     <p:sldId id="280" r:id="rId31"/>
+    <p:sldId id="281" r:id="rId32"/>
     <p:sldId id="261" r:id="rId7"/>
     <p:sldId id="262" r:id="rId8"/>
   </p:sldIdLst>
@@ -1780,6 +1781,76 @@
           <a:p>
             <a:r>
               <a:t>Mesh, OpenTelemetry, Tempo and Kiali resources carry over almost unchanged. What changes is how operators are installed, where metrics live and how things are exposed. Full mapping in docs/openshift-mapping.md.</a:t>
+            </a:r>
+          </a:p>
+        </p:txBody>
+      </p:sp>
+      <p:sp>
+        <p:nvSpPr>
+          <p:cNvPr id="4" name="Slide Number Placeholder 3"/>
+          <p:cNvSpPr>
+            <a:spLocks noGrp="1"/>
+          </p:cNvSpPr>
+          <p:nvPr>
+            <p:ph type="sldNum" idx="5" sz="quarter"/>
+          </p:nvPr>
+        </p:nvSpPr>
+        <p:spPr/>
+      </p:sp>
+    </p:spTree>
+  </p:cSld>
+  <p:clrMapOvr>
+    <a:masterClrMapping/>
+  </p:clrMapOvr>
+</p:notes>
+</file>
+
+<file path=ppt/notesSlides/notesSlide26.xml><?xml version="1.0" encoding="utf-8"?>
+<p:notes xmlns:a="http://schemas.openxmlformats.org/drawingml/2006/main" xmlns:p="http://schemas.openxmlformats.org/presentationml/2006/main" xmlns:r="http://schemas.openxmlformats.org/officeDocument/2006/relationships">
+  <p:cSld>
+    <p:spTree>
+      <p:nvGrpSpPr>
+        <p:cNvPr id="1" name=""/>
+        <p:cNvGrpSpPr/>
+        <p:nvPr/>
+      </p:nvGrpSpPr>
+      <p:grpSpPr>
+        <a:xfrm>
+          <a:off x="0" y="0"/>
+          <a:ext cx="0" cy="0"/>
+          <a:chOff x="0" y="0"/>
+          <a:chExt cx="0" cy="0"/>
+        </a:xfrm>
+      </p:grpSpPr>
+      <p:sp>
+        <p:nvSpPr>
+          <p:cNvPr id="2" name="Slide Image Placeholder 1"/>
+          <p:cNvSpPr>
+            <a:spLocks noGrp="1"/>
+          </p:cNvSpPr>
+          <p:nvPr>
+            <p:ph type="sldImg" idx="2"/>
+          </p:nvPr>
+        </p:nvSpPr>
+        <p:spPr/>
+      </p:sp>
+      <p:sp>
+        <p:nvSpPr>
+          <p:cNvPr id="3" name="Notes Placeholder 2"/>
+          <p:cNvSpPr>
+            <a:spLocks noGrp="1"/>
+          </p:cNvSpPr>
+          <p:nvPr>
+            <p:ph type="body" idx="3" sz="quarter"/>
+          </p:nvPr>
+        </p:nvSpPr>
+        <p:spPr/>
+        <p:txBody>
+          <a:bodyPr/>
+          <a:lstStyle/>
+          <a:p>
+            <a:r>
+              <a:t>Phase 2. The OpenTelemetry SDK for Android (opentelemetry-android) and iOS (opentelemetry-swift) creates a span for each user action and injects the W3C traceparent header into the API call, so the Istio gateway continues the app's trace instead of starting a new one. Every hop in front of OpenShift (CDN, WAF, external API gateway, Route) must forward traceparent. The app's own spans go to a separate, internet-facing collector endpoint with authentication, rate limits, redaction and sampling, which forwards to the internal collector. The journey is still set at the gateway from the route, never from the client. Decisions: whether to trust client-supplied trace IDs, OpenTelemetry versus a commercial RUM product, and consent.</a:t>
             </a:r>
           </a:p>
         </p:txBody>
@@ -23753,6 +23824,2028 @@
 </file>
 
 <file path=ppt/slides/slide24.xml><?xml version="1.0" encoding="utf-8"?>
+<p:sld xmlns:a="http://schemas.openxmlformats.org/drawingml/2006/main" xmlns:p="http://schemas.openxmlformats.org/presentationml/2006/main" xmlns:r="http://schemas.openxmlformats.org/officeDocument/2006/relationships">
+  <p:cSld>
+    <p:spTree>
+      <p:nvGrpSpPr>
+        <p:cNvPr id="1" name=""/>
+        <p:cNvGrpSpPr/>
+        <p:nvPr/>
+      </p:nvGrpSpPr>
+      <p:grpSpPr/>
+      <p:sp>
+        <p:nvSpPr>
+          <p:cNvPr id="2" name="Title 1"/>
+          <p:cNvSpPr>
+            <a:spLocks noGrp="1"/>
+          </p:cNvSpPr>
+          <p:nvPr>
+            <p:ph type="title" idx="100"/>
+          </p:nvPr>
+        </p:nvSpPr>
+        <p:spPr/>
+        <p:txBody>
+          <a:bodyPr/>
+          <a:lstStyle/>
+          <a:p>
+            <a:r>
+              <a:t>Adding the mobile banking app: start the trace at the tap</a:t>
+            </a:r>
+          </a:p>
+        </p:txBody>
+      </p:sp>
+      <p:sp>
+        <p:nvSpPr>
+          <p:cNvPr id="3" name="Slide Number Placeholder 0"/>
+          <p:cNvSpPr>
+            <a:spLocks noGrp="1"/>
+          </p:cNvSpPr>
+          <p:nvPr>
+            <p:ph type="sldNum" sz="quarter" idx="4294967295"/>
+          </p:nvPr>
+        </p:nvSpPr>
+        <p:spPr>
+          <a:xfrm>
+            <a:off x="11247120" y="6400800"/>
+            <a:ext cx="457200" cy="274320"/>
+          </a:xfrm>
+          <a:prstGeom prst="rect">
+            <a:avLst/>
+          </a:prstGeom>
+          <a:extLst>
+            <a:ext uri="{C572A759-6A51-4108-AA02-DFA0A04FC94B}">
+              <ma14:wrappingTextBoxFlag xmlns:ma14="http://schemas.microsoft.com/office/mac/drawingml/2011/main" val="0"/>
+            </a:ext>
+          </a:extLst>
+        </p:spPr>
+        <p:txBody>
+          <a:bodyPr/>
+          <a:lstStyle>
+            <a:lvl1pPr>
+              <a:defRPr sz="1000">
+                <a:solidFill>
+                  <a:schemeClr val="accent5"/>
+                </a:solidFill>
+              </a:defRPr>
+            </a:lvl1pPr>
+          </a:lstStyle>
+          <a:p>
+            <a:pPr algn="r"/>
+            <a:fld id="{F7021451-1387-4CA6-816F-3879F97B5CBC}" type="slidenum">
+              <a:rPr b="0" lang="en-US"/>
+              <a:t>2</a:t>
+            </a:fld>
+            <a:endParaRPr lang="en-US"/>
+          </a:p>
+        </p:txBody>
+      </p:sp>
+      <p:sp>
+        <p:nvSpPr>
+          <p:cNvPr id="4" name="TextBox 3"/>
+          <p:cNvSpPr txBox="1"/>
+          <p:nvPr/>
+        </p:nvSpPr>
+        <p:spPr>
+          <a:xfrm>
+            <a:off x="457200" y="1188720"/>
+            <a:ext cx="11247120" cy="256032"/>
+          </a:xfrm>
+          <a:prstGeom prst="rect">
+            <a:avLst/>
+          </a:prstGeom>
+          <a:noFill/>
+        </p:spPr>
+        <p:txBody>
+          <a:bodyPr wrap="square" lIns="0" rIns="0" tIns="0" bIns="0" anchor="t">
+            <a:spAutoFit/>
+          </a:bodyPr>
+          <a:lstStyle/>
+          <a:p>
+            <a:pPr algn="l">
+              <a:spcAft>
+                <a:spcPts val="400"/>
+              </a:spcAft>
+            </a:pPr>
+            <a:r>
+              <a:rPr sz="1050" b="1" i="0">
+                <a:solidFill>
+                  <a:schemeClr val="tx2"/>
+                </a:solidFill>
+              </a:rPr>
+              <a:t>REQUEST PATH (the same trace ID from the phone to core banking)</a:t>
+            </a:r>
+          </a:p>
+        </p:txBody>
+      </p:sp>
+      <p:sp>
+        <p:nvSpPr>
+          <p:cNvPr id="5" name="Rounded Rectangle 4"/>
+          <p:cNvSpPr/>
+          <p:nvPr/>
+        </p:nvSpPr>
+        <p:spPr>
+          <a:xfrm>
+            <a:off x="457200" y="1508760"/>
+            <a:ext cx="2011680" cy="1051560"/>
+          </a:xfrm>
+          <a:prstGeom prst="roundRect">
+            <a:avLst>
+              <a:gd name="adj" fmla="val 8000"/>
+            </a:avLst>
+          </a:prstGeom>
+          <a:solidFill>
+            <a:schemeClr val="accent5"/>
+          </a:solidFill>
+          <a:ln>
+            <a:noFill/>
+          </a:ln>
+          <a:effectLst/>
+        </p:spPr>
+        <p:style>
+          <a:lnRef idx="1">
+            <a:schemeClr val="accent1"/>
+          </a:lnRef>
+          <a:fillRef idx="3">
+            <a:schemeClr val="accent1"/>
+          </a:fillRef>
+          <a:effectRef idx="2">
+            <a:schemeClr val="accent1"/>
+          </a:effectRef>
+          <a:fontRef idx="minor">
+            <a:schemeClr val="lt1"/>
+          </a:fontRef>
+        </p:style>
+        <p:txBody>
+          <a:bodyPr rtlCol="0" anchor="ctr" wrap="square" lIns="73152" rIns="73152" tIns="43891" bIns="43891"/>
+          <a:lstStyle/>
+          <a:p>
+            <a:pPr algn="ctr">
+              <a:spcAft>
+                <a:spcPts val="400"/>
+              </a:spcAft>
+            </a:pPr>
+            <a:r>
+              <a:rPr sz="1200" b="1" i="0">
+                <a:solidFill>
+                  <a:schemeClr val="bg1"/>
+                </a:solidFill>
+              </a:rPr>
+              <a:t>Mobile banking app</a:t>
+            </a:r>
+          </a:p>
+          <a:p>
+            <a:pPr algn="ctr">
+              <a:spcAft>
+                <a:spcPts val="400"/>
+              </a:spcAft>
+            </a:pPr>
+            <a:r>
+              <a:rPr sz="1000" b="0" i="0">
+                <a:solidFill>
+                  <a:schemeClr val="bg1"/>
+                </a:solidFill>
+              </a:rPr>
+              <a:t>OTel SDK (Android / iOS)
+span per tap: "Transfer"</a:t>
+            </a:r>
+          </a:p>
+        </p:txBody>
+      </p:sp>
+      <p:sp>
+        <p:nvSpPr>
+          <p:cNvPr id="6" name="Rounded Rectangle 5"/>
+          <p:cNvSpPr/>
+          <p:nvPr/>
+        </p:nvSpPr>
+        <p:spPr>
+          <a:xfrm>
+            <a:off x="2766060" y="1508760"/>
+            <a:ext cx="2011680" cy="1051560"/>
+          </a:xfrm>
+          <a:prstGeom prst="roundRect">
+            <a:avLst>
+              <a:gd name="adj" fmla="val 8000"/>
+            </a:avLst>
+          </a:prstGeom>
+          <a:solidFill>
+            <a:schemeClr val="accent5"/>
+          </a:solidFill>
+          <a:ln>
+            <a:noFill/>
+          </a:ln>
+          <a:effectLst/>
+        </p:spPr>
+        <p:style>
+          <a:lnRef idx="1">
+            <a:schemeClr val="accent1"/>
+          </a:lnRef>
+          <a:fillRef idx="3">
+            <a:schemeClr val="accent1"/>
+          </a:fillRef>
+          <a:effectRef idx="2">
+            <a:schemeClr val="accent1"/>
+          </a:effectRef>
+          <a:fontRef idx="minor">
+            <a:schemeClr val="lt1"/>
+          </a:fontRef>
+        </p:style>
+        <p:txBody>
+          <a:bodyPr rtlCol="0" anchor="ctr" wrap="square" lIns="73152" rIns="73152" tIns="43891" bIns="43891"/>
+          <a:lstStyle/>
+          <a:p>
+            <a:pPr algn="ctr">
+              <a:spcAft>
+                <a:spcPts val="400"/>
+              </a:spcAft>
+            </a:pPr>
+            <a:r>
+              <a:rPr sz="1200" b="1" i="0">
+                <a:solidFill>
+                  <a:schemeClr val="bg1"/>
+                </a:solidFill>
+              </a:rPr>
+              <a:t>Edge: CDN / WAF /
+API gateway</a:t>
+            </a:r>
+          </a:p>
+          <a:p>
+            <a:pPr algn="ctr">
+              <a:spcAft>
+                <a:spcPts val="400"/>
+              </a:spcAft>
+            </a:pPr>
+            <a:r>
+              <a:rPr sz="1000" b="0" i="0">
+                <a:solidFill>
+                  <a:schemeClr val="bg1"/>
+                </a:solidFill>
+              </a:rPr>
+              <a:t>must forward traceparent
+(header allow-list)</a:t>
+            </a:r>
+          </a:p>
+        </p:txBody>
+      </p:sp>
+      <p:cxnSp>
+        <p:nvCxnSpPr>
+          <p:cNvPr id="7" name="Connector 6"/>
+          <p:cNvCxnSpPr/>
+          <p:nvPr/>
+        </p:nvCxnSpPr>
+        <p:spPr>
+          <a:xfrm>
+            <a:off x="2468880" y="2034540"/>
+            <a:ext cx="297180" cy="0"/>
+          </a:xfrm>
+          <a:prstGeom prst="line">
+            <a:avLst/>
+          </a:prstGeom>
+          <a:ln w="15875">
+            <a:solidFill>
+              <a:schemeClr val="tx2"/>
+            </a:solidFill>
+            <a:tailEnd type="triangle"/>
+          </a:ln>
+        </p:spPr>
+        <p:style>
+          <a:lnRef idx="2">
+            <a:schemeClr val="accent1"/>
+          </a:lnRef>
+          <a:fillRef idx="0">
+            <a:schemeClr val="accent1"/>
+          </a:fillRef>
+          <a:effectRef idx="1">
+            <a:schemeClr val="accent1"/>
+          </a:effectRef>
+          <a:fontRef idx="minor">
+            <a:schemeClr val="tx1"/>
+          </a:fontRef>
+        </p:style>
+      </p:cxnSp>
+      <p:sp>
+        <p:nvSpPr>
+          <p:cNvPr id="8" name="Rounded Rectangle 7"/>
+          <p:cNvSpPr/>
+          <p:nvPr/>
+        </p:nvSpPr>
+        <p:spPr>
+          <a:xfrm>
+            <a:off x="5074920" y="1508760"/>
+            <a:ext cx="2011680" cy="1051560"/>
+          </a:xfrm>
+          <a:prstGeom prst="roundRect">
+            <a:avLst>
+              <a:gd name="adj" fmla="val 8000"/>
+            </a:avLst>
+          </a:prstGeom>
+          <a:solidFill>
+            <a:schemeClr val="accent2"/>
+          </a:solidFill>
+          <a:ln>
+            <a:noFill/>
+          </a:ln>
+          <a:effectLst/>
+        </p:spPr>
+        <p:style>
+          <a:lnRef idx="1">
+            <a:schemeClr val="accent1"/>
+          </a:lnRef>
+          <a:fillRef idx="3">
+            <a:schemeClr val="accent1"/>
+          </a:fillRef>
+          <a:effectRef idx="2">
+            <a:schemeClr val="accent1"/>
+          </a:effectRef>
+          <a:fontRef idx="minor">
+            <a:schemeClr val="lt1"/>
+          </a:fontRef>
+        </p:style>
+        <p:txBody>
+          <a:bodyPr rtlCol="0" anchor="ctr" wrap="square" lIns="73152" rIns="73152" tIns="43891" bIns="43891"/>
+          <a:lstStyle/>
+          <a:p>
+            <a:pPr algn="ctr">
+              <a:spcAft>
+                <a:spcPts val="400"/>
+              </a:spcAft>
+            </a:pPr>
+            <a:r>
+              <a:rPr sz="1200" b="1" i="0">
+                <a:solidFill>
+                  <a:schemeClr val="bg1"/>
+                </a:solidFill>
+              </a:rPr>
+              <a:t>OpenShift Route</a:t>
+            </a:r>
+          </a:p>
+          <a:p>
+            <a:pPr algn="ctr">
+              <a:spcAft>
+                <a:spcPts val="400"/>
+              </a:spcAft>
+            </a:pPr>
+            <a:r>
+              <a:rPr sz="1000" b="0" i="0">
+                <a:solidFill>
+                  <a:schemeClr val="bg1"/>
+                </a:solidFill>
+              </a:rPr>
+              <a:t>passes headers through</a:t>
+            </a:r>
+          </a:p>
+        </p:txBody>
+      </p:sp>
+      <p:cxnSp>
+        <p:nvCxnSpPr>
+          <p:cNvPr id="9" name="Connector 8"/>
+          <p:cNvCxnSpPr/>
+          <p:nvPr/>
+        </p:nvCxnSpPr>
+        <p:spPr>
+          <a:xfrm>
+            <a:off x="4777740" y="2034540"/>
+            <a:ext cx="297180" cy="0"/>
+          </a:xfrm>
+          <a:prstGeom prst="line">
+            <a:avLst/>
+          </a:prstGeom>
+          <a:ln w="15875">
+            <a:solidFill>
+              <a:schemeClr val="tx2"/>
+            </a:solidFill>
+            <a:tailEnd type="triangle"/>
+          </a:ln>
+        </p:spPr>
+        <p:style>
+          <a:lnRef idx="2">
+            <a:schemeClr val="accent1"/>
+          </a:lnRef>
+          <a:fillRef idx="0">
+            <a:schemeClr val="accent1"/>
+          </a:fillRef>
+          <a:effectRef idx="1">
+            <a:schemeClr val="accent1"/>
+          </a:effectRef>
+          <a:fontRef idx="minor">
+            <a:schemeClr val="tx1"/>
+          </a:fontRef>
+        </p:style>
+      </p:cxnSp>
+      <p:sp>
+        <p:nvSpPr>
+          <p:cNvPr id="10" name="Rounded Rectangle 9"/>
+          <p:cNvSpPr/>
+          <p:nvPr/>
+        </p:nvSpPr>
+        <p:spPr>
+          <a:xfrm>
+            <a:off x="7383780" y="1508760"/>
+            <a:ext cx="2011680" cy="1051560"/>
+          </a:xfrm>
+          <a:prstGeom prst="roundRect">
+            <a:avLst>
+              <a:gd name="adj" fmla="val 8000"/>
+            </a:avLst>
+          </a:prstGeom>
+          <a:solidFill>
+            <a:schemeClr val="accent2"/>
+          </a:solidFill>
+          <a:ln>
+            <a:noFill/>
+          </a:ln>
+          <a:effectLst/>
+        </p:spPr>
+        <p:style>
+          <a:lnRef idx="1">
+            <a:schemeClr val="accent1"/>
+          </a:lnRef>
+          <a:fillRef idx="3">
+            <a:schemeClr val="accent1"/>
+          </a:fillRef>
+          <a:effectRef idx="2">
+            <a:schemeClr val="accent1"/>
+          </a:effectRef>
+          <a:fontRef idx="minor">
+            <a:schemeClr val="lt1"/>
+          </a:fontRef>
+        </p:style>
+        <p:txBody>
+          <a:bodyPr rtlCol="0" anchor="ctr" wrap="square" lIns="73152" rIns="73152" tIns="43891" bIns="43891"/>
+          <a:lstStyle/>
+          <a:p>
+            <a:pPr algn="ctr">
+              <a:spcAft>
+                <a:spcPts val="400"/>
+              </a:spcAft>
+            </a:pPr>
+            <a:r>
+              <a:rPr sz="1200" b="1" i="0">
+                <a:solidFill>
+                  <a:schemeClr val="bg1"/>
+                </a:solidFill>
+              </a:rPr>
+              <a:t>Istio ingress gateway</a:t>
+            </a:r>
+          </a:p>
+          <a:p>
+            <a:pPr algn="ctr">
+              <a:spcAft>
+                <a:spcPts val="400"/>
+              </a:spcAft>
+            </a:pPr>
+            <a:r>
+              <a:rPr sz="1000" b="0" i="0">
+                <a:solidFill>
+                  <a:schemeClr val="bg1"/>
+                </a:solidFill>
+              </a:rPr>
+              <a:t>continues the app's trace;
+sets journey from the route</a:t>
+            </a:r>
+          </a:p>
+        </p:txBody>
+      </p:sp>
+      <p:cxnSp>
+        <p:nvCxnSpPr>
+          <p:cNvPr id="11" name="Connector 10"/>
+          <p:cNvCxnSpPr/>
+          <p:nvPr/>
+        </p:nvCxnSpPr>
+        <p:spPr>
+          <a:xfrm>
+            <a:off x="7086600" y="2034540"/>
+            <a:ext cx="297180" cy="0"/>
+          </a:xfrm>
+          <a:prstGeom prst="line">
+            <a:avLst/>
+          </a:prstGeom>
+          <a:ln w="15875">
+            <a:solidFill>
+              <a:schemeClr val="tx2"/>
+            </a:solidFill>
+            <a:tailEnd type="triangle"/>
+          </a:ln>
+        </p:spPr>
+        <p:style>
+          <a:lnRef idx="2">
+            <a:schemeClr val="accent1"/>
+          </a:lnRef>
+          <a:fillRef idx="0">
+            <a:schemeClr val="accent1"/>
+          </a:fillRef>
+          <a:effectRef idx="1">
+            <a:schemeClr val="accent1"/>
+          </a:effectRef>
+          <a:fontRef idx="minor">
+            <a:schemeClr val="tx1"/>
+          </a:fontRef>
+        </p:style>
+      </p:cxnSp>
+      <p:sp>
+        <p:nvSpPr>
+          <p:cNvPr id="12" name="Rounded Rectangle 11"/>
+          <p:cNvSpPr/>
+          <p:nvPr/>
+        </p:nvSpPr>
+        <p:spPr>
+          <a:xfrm>
+            <a:off x="9692640" y="1508760"/>
+            <a:ext cx="2011680" cy="1051560"/>
+          </a:xfrm>
+          <a:prstGeom prst="roundRect">
+            <a:avLst>
+              <a:gd name="adj" fmla="val 8000"/>
+            </a:avLst>
+          </a:prstGeom>
+          <a:solidFill>
+            <a:schemeClr val="accent2"/>
+          </a:solidFill>
+          <a:ln>
+            <a:noFill/>
+          </a:ln>
+          <a:effectLst/>
+        </p:spPr>
+        <p:style>
+          <a:lnRef idx="1">
+            <a:schemeClr val="accent1"/>
+          </a:lnRef>
+          <a:fillRef idx="3">
+            <a:schemeClr val="accent1"/>
+          </a:fillRef>
+          <a:effectRef idx="2">
+            <a:schemeClr val="accent1"/>
+          </a:effectRef>
+          <a:fontRef idx="minor">
+            <a:schemeClr val="lt1"/>
+          </a:fontRef>
+        </p:style>
+        <p:txBody>
+          <a:bodyPr rtlCol="0" anchor="ctr" wrap="square" lIns="73152" rIns="73152" tIns="43891" bIns="43891"/>
+          <a:lstStyle/>
+          <a:p>
+            <a:pPr algn="ctr">
+              <a:spcAft>
+                <a:spcPts val="400"/>
+              </a:spcAft>
+            </a:pPr>
+            <a:r>
+              <a:rPr sz="1200" b="1" i="0">
+                <a:solidFill>
+                  <a:schemeClr val="bg1"/>
+                </a:solidFill>
+              </a:rPr>
+              <a:t>payments-svc ...</a:t>
+            </a:r>
+          </a:p>
+          <a:p>
+            <a:pPr algn="ctr">
+              <a:spcAft>
+                <a:spcPts val="400"/>
+              </a:spcAft>
+            </a:pPr>
+            <a:r>
+              <a:rPr sz="1000" b="0" i="0">
+                <a:solidFill>
+                  <a:schemeClr val="bg1"/>
+                </a:solidFill>
+              </a:rPr>
+              <a:t>same trace ID to the
+core banking call</a:t>
+            </a:r>
+          </a:p>
+        </p:txBody>
+      </p:sp>
+      <p:cxnSp>
+        <p:nvCxnSpPr>
+          <p:cNvPr id="13" name="Connector 12"/>
+          <p:cNvCxnSpPr/>
+          <p:nvPr/>
+        </p:nvCxnSpPr>
+        <p:spPr>
+          <a:xfrm>
+            <a:off x="9395460" y="2034540"/>
+            <a:ext cx="297180" cy="0"/>
+          </a:xfrm>
+          <a:prstGeom prst="line">
+            <a:avLst/>
+          </a:prstGeom>
+          <a:ln w="15875">
+            <a:solidFill>
+              <a:schemeClr val="tx2"/>
+            </a:solidFill>
+            <a:tailEnd type="triangle"/>
+          </a:ln>
+        </p:spPr>
+        <p:style>
+          <a:lnRef idx="2">
+            <a:schemeClr val="accent1"/>
+          </a:lnRef>
+          <a:fillRef idx="0">
+            <a:schemeClr val="accent1"/>
+          </a:fillRef>
+          <a:effectRef idx="1">
+            <a:schemeClr val="accent1"/>
+          </a:effectRef>
+          <a:fontRef idx="minor">
+            <a:schemeClr val="tx1"/>
+          </a:fontRef>
+        </p:style>
+      </p:cxnSp>
+      <p:sp>
+        <p:nvSpPr>
+          <p:cNvPr id="14" name="TextBox 13"/>
+          <p:cNvSpPr txBox="1"/>
+          <p:nvPr/>
+        </p:nvSpPr>
+        <p:spPr>
+          <a:xfrm>
+            <a:off x="2468880" y="2587752"/>
+            <a:ext cx="2377440" cy="256032"/>
+          </a:xfrm>
+          <a:prstGeom prst="rect">
+            <a:avLst/>
+          </a:prstGeom>
+          <a:noFill/>
+        </p:spPr>
+        <p:txBody>
+          <a:bodyPr wrap="square" lIns="0" rIns="0" tIns="0" bIns="0" anchor="t">
+            <a:spAutoFit/>
+          </a:bodyPr>
+          <a:lstStyle/>
+          <a:p>
+            <a:pPr algn="l">
+              <a:spcAft>
+                <a:spcPts val="400"/>
+              </a:spcAft>
+            </a:pPr>
+            <a:r>
+              <a:rPr sz="950" b="0" i="1">
+                <a:solidFill>
+                  <a:schemeClr val="tx2"/>
+                </a:solidFill>
+              </a:rPr>
+              <a:t>HTTPS + traceparent + x-channel: mobile</a:t>
+            </a:r>
+          </a:p>
+        </p:txBody>
+      </p:sp>
+      <p:sp>
+        <p:nvSpPr>
+          <p:cNvPr id="15" name="TextBox 14"/>
+          <p:cNvSpPr txBox="1"/>
+          <p:nvPr/>
+        </p:nvSpPr>
+        <p:spPr>
+          <a:xfrm>
+            <a:off x="457200" y="2926080"/>
+            <a:ext cx="11247120" cy="256032"/>
+          </a:xfrm>
+          <a:prstGeom prst="rect">
+            <a:avLst/>
+          </a:prstGeom>
+          <a:noFill/>
+        </p:spPr>
+        <p:txBody>
+          <a:bodyPr wrap="square" lIns="0" rIns="0" tIns="0" bIns="0" anchor="t">
+            <a:spAutoFit/>
+          </a:bodyPr>
+          <a:lstStyle/>
+          <a:p>
+            <a:pPr algn="l">
+              <a:spcAft>
+                <a:spcPts val="400"/>
+              </a:spcAft>
+            </a:pPr>
+            <a:r>
+              <a:rPr sz="1050" b="1" i="0">
+                <a:solidFill>
+                  <a:schemeClr val="tx2"/>
+                </a:solidFill>
+              </a:rPr>
+              <a:t>TELEMETRY PATH (the app's own spans, PUSHED over OTLP/HTTPS; each arrow starts at the sender)</a:t>
+            </a:r>
+          </a:p>
+        </p:txBody>
+      </p:sp>
+      <p:sp>
+        <p:nvSpPr>
+          <p:cNvPr id="16" name="Rounded Rectangle 15"/>
+          <p:cNvSpPr/>
+          <p:nvPr/>
+        </p:nvSpPr>
+        <p:spPr>
+          <a:xfrm>
+            <a:off x="457200" y="3246120"/>
+            <a:ext cx="2011680" cy="960120"/>
+          </a:xfrm>
+          <a:prstGeom prst="roundRect">
+            <a:avLst>
+              <a:gd name="adj" fmla="val 8000"/>
+            </a:avLst>
+          </a:prstGeom>
+          <a:solidFill>
+            <a:schemeClr val="accent5"/>
+          </a:solidFill>
+          <a:ln>
+            <a:noFill/>
+          </a:ln>
+          <a:effectLst/>
+        </p:spPr>
+        <p:style>
+          <a:lnRef idx="1">
+            <a:schemeClr val="accent1"/>
+          </a:lnRef>
+          <a:fillRef idx="3">
+            <a:schemeClr val="accent1"/>
+          </a:fillRef>
+          <a:effectRef idx="2">
+            <a:schemeClr val="accent1"/>
+          </a:effectRef>
+          <a:fontRef idx="minor">
+            <a:schemeClr val="lt1"/>
+          </a:fontRef>
+        </p:style>
+        <p:txBody>
+          <a:bodyPr rtlCol="0" anchor="ctr" wrap="square" lIns="73152" rIns="73152" tIns="43891" bIns="43891"/>
+          <a:lstStyle/>
+          <a:p>
+            <a:pPr algn="ctr">
+              <a:spcAft>
+                <a:spcPts val="400"/>
+              </a:spcAft>
+            </a:pPr>
+            <a:r>
+              <a:rPr sz="1200" b="1" i="0">
+                <a:solidFill>
+                  <a:schemeClr val="bg1"/>
+                </a:solidFill>
+              </a:rPr>
+              <a:t>Mobile banking app</a:t>
+            </a:r>
+          </a:p>
+          <a:p>
+            <a:pPr algn="ctr">
+              <a:spcAft>
+                <a:spcPts val="400"/>
+              </a:spcAft>
+            </a:pPr>
+            <a:r>
+              <a:rPr sz="1000" b="0" i="0">
+                <a:solidFill>
+                  <a:schemeClr val="bg1"/>
+                </a:solidFill>
+              </a:rPr>
+              <a:t>batched, gzip, on Wi-Fi
+or when idle</a:t>
+            </a:r>
+          </a:p>
+        </p:txBody>
+      </p:sp>
+      <p:sp>
+        <p:nvSpPr>
+          <p:cNvPr id="17" name="Rounded Rectangle 16"/>
+          <p:cNvSpPr/>
+          <p:nvPr/>
+        </p:nvSpPr>
+        <p:spPr>
+          <a:xfrm>
+            <a:off x="2766060" y="3246120"/>
+            <a:ext cx="2011680" cy="960120"/>
+          </a:xfrm>
+          <a:prstGeom prst="roundRect">
+            <a:avLst>
+              <a:gd name="adj" fmla="val 8000"/>
+            </a:avLst>
+          </a:prstGeom>
+          <a:solidFill>
+            <a:schemeClr val="accent1"/>
+          </a:solidFill>
+          <a:ln>
+            <a:noFill/>
+          </a:ln>
+          <a:effectLst/>
+        </p:spPr>
+        <p:style>
+          <a:lnRef idx="1">
+            <a:schemeClr val="accent1"/>
+          </a:lnRef>
+          <a:fillRef idx="3">
+            <a:schemeClr val="accent1"/>
+          </a:fillRef>
+          <a:effectRef idx="2">
+            <a:schemeClr val="accent1"/>
+          </a:effectRef>
+          <a:fontRef idx="minor">
+            <a:schemeClr val="lt1"/>
+          </a:fontRef>
+        </p:style>
+        <p:txBody>
+          <a:bodyPr rtlCol="0" anchor="ctr" wrap="square" lIns="73152" rIns="73152" tIns="43891" bIns="43891"/>
+          <a:lstStyle/>
+          <a:p>
+            <a:pPr algn="ctr">
+              <a:spcAft>
+                <a:spcPts val="400"/>
+              </a:spcAft>
+            </a:pPr>
+            <a:r>
+              <a:rPr sz="1200" b="1" i="0">
+                <a:solidFill>
+                  <a:schemeClr val="bg1"/>
+                </a:solidFill>
+              </a:rPr>
+              <a:t>Public OTLP endpoint</a:t>
+            </a:r>
+          </a:p>
+          <a:p>
+            <a:pPr algn="ctr">
+              <a:spcAft>
+                <a:spcPts val="400"/>
+              </a:spcAft>
+            </a:pPr>
+            <a:r>
+              <a:rPr sz="1000" b="0" i="0">
+                <a:solidFill>
+                  <a:schemeClr val="bg1"/>
+                </a:solidFill>
+              </a:rPr>
+              <a:t>Route + auth (app token),
+rate limit, size limits</a:t>
+            </a:r>
+          </a:p>
+        </p:txBody>
+      </p:sp>
+      <p:cxnSp>
+        <p:nvCxnSpPr>
+          <p:cNvPr id="18" name="Connector 17"/>
+          <p:cNvCxnSpPr/>
+          <p:nvPr/>
+        </p:nvCxnSpPr>
+        <p:spPr>
+          <a:xfrm>
+            <a:off x="2468880" y="3726180"/>
+            <a:ext cx="297180" cy="0"/>
+          </a:xfrm>
+          <a:prstGeom prst="line">
+            <a:avLst/>
+          </a:prstGeom>
+          <a:ln w="15875">
+            <a:solidFill>
+              <a:schemeClr val="tx2"/>
+            </a:solidFill>
+            <a:tailEnd type="triangle"/>
+          </a:ln>
+        </p:spPr>
+        <p:style>
+          <a:lnRef idx="2">
+            <a:schemeClr val="accent1"/>
+          </a:lnRef>
+          <a:fillRef idx="0">
+            <a:schemeClr val="accent1"/>
+          </a:fillRef>
+          <a:effectRef idx="1">
+            <a:schemeClr val="accent1"/>
+          </a:effectRef>
+          <a:fontRef idx="minor">
+            <a:schemeClr val="tx1"/>
+          </a:fontRef>
+        </p:style>
+      </p:cxnSp>
+      <p:sp>
+        <p:nvSpPr>
+          <p:cNvPr id="19" name="Rounded Rectangle 18"/>
+          <p:cNvSpPr/>
+          <p:nvPr/>
+        </p:nvSpPr>
+        <p:spPr>
+          <a:xfrm>
+            <a:off x="5074920" y="3246120"/>
+            <a:ext cx="2011680" cy="960120"/>
+          </a:xfrm>
+          <a:prstGeom prst="roundRect">
+            <a:avLst>
+              <a:gd name="adj" fmla="val 8000"/>
+            </a:avLst>
+          </a:prstGeom>
+          <a:solidFill>
+            <a:schemeClr val="accent1"/>
+          </a:solidFill>
+          <a:ln>
+            <a:noFill/>
+          </a:ln>
+          <a:effectLst/>
+        </p:spPr>
+        <p:style>
+          <a:lnRef idx="1">
+            <a:schemeClr val="accent1"/>
+          </a:lnRef>
+          <a:fillRef idx="3">
+            <a:schemeClr val="accent1"/>
+          </a:fillRef>
+          <a:effectRef idx="2">
+            <a:schemeClr val="accent1"/>
+          </a:effectRef>
+          <a:fontRef idx="minor">
+            <a:schemeClr val="lt1"/>
+          </a:fontRef>
+        </p:style>
+        <p:txBody>
+          <a:bodyPr rtlCol="0" anchor="ctr" wrap="square" lIns="73152" rIns="73152" tIns="43891" bIns="43891"/>
+          <a:lstStyle/>
+          <a:p>
+            <a:pPr algn="ctr">
+              <a:spcAft>
+                <a:spcPts val="400"/>
+              </a:spcAft>
+            </a:pPr>
+            <a:r>
+              <a:rPr sz="1200" b="1" i="0">
+                <a:solidFill>
+                  <a:schemeClr val="bg1"/>
+                </a:solidFill>
+              </a:rPr>
+              <a:t>Edge collector</a:t>
+            </a:r>
+          </a:p>
+          <a:p>
+            <a:pPr algn="ctr">
+              <a:spcAft>
+                <a:spcPts val="400"/>
+              </a:spcAft>
+            </a:pPr>
+            <a:r>
+              <a:rPr sz="1000" b="0" i="0">
+                <a:solidFill>
+                  <a:schemeClr val="bg1"/>
+                </a:solidFill>
+              </a:rPr>
+              <a:t>redact PII (allow-list),
+sample: errors + 10% sessions</a:t>
+            </a:r>
+          </a:p>
+        </p:txBody>
+      </p:sp>
+      <p:cxnSp>
+        <p:nvCxnSpPr>
+          <p:cNvPr id="20" name="Connector 19"/>
+          <p:cNvCxnSpPr/>
+          <p:nvPr/>
+        </p:nvCxnSpPr>
+        <p:spPr>
+          <a:xfrm>
+            <a:off x="4777740" y="3726180"/>
+            <a:ext cx="297180" cy="0"/>
+          </a:xfrm>
+          <a:prstGeom prst="line">
+            <a:avLst/>
+          </a:prstGeom>
+          <a:ln w="15875">
+            <a:solidFill>
+              <a:schemeClr val="tx2"/>
+            </a:solidFill>
+            <a:tailEnd type="triangle"/>
+          </a:ln>
+        </p:spPr>
+        <p:style>
+          <a:lnRef idx="2">
+            <a:schemeClr val="accent1"/>
+          </a:lnRef>
+          <a:fillRef idx="0">
+            <a:schemeClr val="accent1"/>
+          </a:fillRef>
+          <a:effectRef idx="1">
+            <a:schemeClr val="accent1"/>
+          </a:effectRef>
+          <a:fontRef idx="minor">
+            <a:schemeClr val="tx1"/>
+          </a:fontRef>
+        </p:style>
+      </p:cxnSp>
+      <p:sp>
+        <p:nvSpPr>
+          <p:cNvPr id="21" name="Rounded Rectangle 20"/>
+          <p:cNvSpPr/>
+          <p:nvPr/>
+        </p:nvSpPr>
+        <p:spPr>
+          <a:xfrm>
+            <a:off x="7383780" y="3246120"/>
+            <a:ext cx="2011680" cy="960120"/>
+          </a:xfrm>
+          <a:prstGeom prst="roundRect">
+            <a:avLst>
+              <a:gd name="adj" fmla="val 8000"/>
+            </a:avLst>
+          </a:prstGeom>
+          <a:solidFill>
+            <a:schemeClr val="accent1"/>
+          </a:solidFill>
+          <a:ln>
+            <a:noFill/>
+          </a:ln>
+          <a:effectLst/>
+        </p:spPr>
+        <p:style>
+          <a:lnRef idx="1">
+            <a:schemeClr val="accent1"/>
+          </a:lnRef>
+          <a:fillRef idx="3">
+            <a:schemeClr val="accent1"/>
+          </a:fillRef>
+          <a:effectRef idx="2">
+            <a:schemeClr val="accent1"/>
+          </a:effectRef>
+          <a:fontRef idx="minor">
+            <a:schemeClr val="lt1"/>
+          </a:fontRef>
+        </p:style>
+        <p:txBody>
+          <a:bodyPr rtlCol="0" anchor="ctr" wrap="square" lIns="73152" rIns="73152" tIns="43891" bIns="43891"/>
+          <a:lstStyle/>
+          <a:p>
+            <a:pPr algn="ctr">
+              <a:spcAft>
+                <a:spcPts val="400"/>
+              </a:spcAft>
+            </a:pPr>
+            <a:r>
+              <a:rPr sz="1200" b="1" i="0">
+                <a:solidFill>
+                  <a:schemeClr val="bg1"/>
+                </a:solidFill>
+              </a:rPr>
+              <a:t>Internal OTel Collector</a:t>
+            </a:r>
+          </a:p>
+          <a:p>
+            <a:pPr algn="ctr">
+              <a:spcAft>
+                <a:spcPts val="400"/>
+              </a:spcAft>
+            </a:pPr>
+            <a:r>
+              <a:rPr sz="1000" b="0" i="0">
+                <a:solidFill>
+                  <a:schemeClr val="bg1"/>
+                </a:solidFill>
+              </a:rPr>
+              <a:t>same pipeline as the
+mesh: journey, tail sampling</a:t>
+            </a:r>
+          </a:p>
+        </p:txBody>
+      </p:sp>
+      <p:cxnSp>
+        <p:nvCxnSpPr>
+          <p:cNvPr id="22" name="Connector 21"/>
+          <p:cNvCxnSpPr/>
+          <p:nvPr/>
+        </p:nvCxnSpPr>
+        <p:spPr>
+          <a:xfrm>
+            <a:off x="7086600" y="3726180"/>
+            <a:ext cx="297180" cy="0"/>
+          </a:xfrm>
+          <a:prstGeom prst="line">
+            <a:avLst/>
+          </a:prstGeom>
+          <a:ln w="15875">
+            <a:solidFill>
+              <a:schemeClr val="tx2"/>
+            </a:solidFill>
+            <a:tailEnd type="triangle"/>
+          </a:ln>
+        </p:spPr>
+        <p:style>
+          <a:lnRef idx="2">
+            <a:schemeClr val="accent1"/>
+          </a:lnRef>
+          <a:fillRef idx="0">
+            <a:schemeClr val="accent1"/>
+          </a:fillRef>
+          <a:effectRef idx="1">
+            <a:schemeClr val="accent1"/>
+          </a:effectRef>
+          <a:fontRef idx="minor">
+            <a:schemeClr val="tx1"/>
+          </a:fontRef>
+        </p:style>
+      </p:cxnSp>
+      <p:sp>
+        <p:nvSpPr>
+          <p:cNvPr id="23" name="Rounded Rectangle 22"/>
+          <p:cNvSpPr/>
+          <p:nvPr/>
+        </p:nvSpPr>
+        <p:spPr>
+          <a:xfrm>
+            <a:off x="9692640" y="3246120"/>
+            <a:ext cx="2011680" cy="960120"/>
+          </a:xfrm>
+          <a:prstGeom prst="roundRect">
+            <a:avLst>
+              <a:gd name="adj" fmla="val 8000"/>
+            </a:avLst>
+          </a:prstGeom>
+          <a:solidFill>
+            <a:schemeClr val="accent1"/>
+          </a:solidFill>
+          <a:ln>
+            <a:noFill/>
+          </a:ln>
+          <a:effectLst/>
+        </p:spPr>
+        <p:style>
+          <a:lnRef idx="1">
+            <a:schemeClr val="accent1"/>
+          </a:lnRef>
+          <a:fillRef idx="3">
+            <a:schemeClr val="accent1"/>
+          </a:fillRef>
+          <a:effectRef idx="2">
+            <a:schemeClr val="accent1"/>
+          </a:effectRef>
+          <a:fontRef idx="minor">
+            <a:schemeClr val="lt1"/>
+          </a:fontRef>
+        </p:style>
+        <p:txBody>
+          <a:bodyPr rtlCol="0" anchor="ctr" wrap="square" lIns="73152" rIns="73152" tIns="43891" bIns="43891"/>
+          <a:lstStyle/>
+          <a:p>
+            <a:pPr algn="ctr">
+              <a:spcAft>
+                <a:spcPts val="400"/>
+              </a:spcAft>
+            </a:pPr>
+            <a:r>
+              <a:rPr sz="1200" b="1" i="0">
+                <a:solidFill>
+                  <a:schemeClr val="bg1"/>
+                </a:solidFill>
+              </a:rPr>
+              <a:t>Tempo / Prometheus / Loki</a:t>
+            </a:r>
+          </a:p>
+          <a:p>
+            <a:pPr algn="ctr">
+              <a:spcAft>
+                <a:spcPts val="400"/>
+              </a:spcAft>
+            </a:pPr>
+            <a:r>
+              <a:rPr sz="1000" b="0" i="0">
+                <a:solidFill>
+                  <a:schemeClr val="bg1"/>
+                </a:solidFill>
+              </a:rPr>
+              <a:t>traces; RED metrics from
+spans; crash reports</a:t>
+            </a:r>
+          </a:p>
+        </p:txBody>
+      </p:sp>
+      <p:cxnSp>
+        <p:nvCxnSpPr>
+          <p:cNvPr id="24" name="Connector 23"/>
+          <p:cNvCxnSpPr/>
+          <p:nvPr/>
+        </p:nvCxnSpPr>
+        <p:spPr>
+          <a:xfrm>
+            <a:off x="9395460" y="3726180"/>
+            <a:ext cx="297180" cy="0"/>
+          </a:xfrm>
+          <a:prstGeom prst="line">
+            <a:avLst/>
+          </a:prstGeom>
+          <a:ln w="15875">
+            <a:solidFill>
+              <a:schemeClr val="tx2"/>
+            </a:solidFill>
+            <a:tailEnd type="triangle"/>
+          </a:ln>
+        </p:spPr>
+        <p:style>
+          <a:lnRef idx="2">
+            <a:schemeClr val="accent1"/>
+          </a:lnRef>
+          <a:fillRef idx="0">
+            <a:schemeClr val="accent1"/>
+          </a:fillRef>
+          <a:effectRef idx="1">
+            <a:schemeClr val="accent1"/>
+          </a:effectRef>
+          <a:fontRef idx="minor">
+            <a:schemeClr val="tx1"/>
+          </a:fontRef>
+        </p:style>
+      </p:cxnSp>
+      <p:sp>
+        <p:nvSpPr>
+          <p:cNvPr id="25" name="Rounded Rectangle 24"/>
+          <p:cNvSpPr/>
+          <p:nvPr/>
+        </p:nvSpPr>
+        <p:spPr>
+          <a:xfrm>
+            <a:off x="457200" y="4434840"/>
+            <a:ext cx="2651760" cy="1691640"/>
+          </a:xfrm>
+          <a:prstGeom prst="roundRect">
+            <a:avLst>
+              <a:gd name="adj" fmla="val 8000"/>
+            </a:avLst>
+          </a:prstGeom>
+          <a:solidFill>
+            <a:schemeClr val="bg2"/>
+          </a:solidFill>
+          <a:ln>
+            <a:noFill/>
+          </a:ln>
+          <a:effectLst/>
+        </p:spPr>
+        <p:style>
+          <a:lnRef idx="1">
+            <a:schemeClr val="accent1"/>
+          </a:lnRef>
+          <a:fillRef idx="3">
+            <a:schemeClr val="accent1"/>
+          </a:fillRef>
+          <a:effectRef idx="2">
+            <a:schemeClr val="accent1"/>
+          </a:effectRef>
+          <a:fontRef idx="minor">
+            <a:schemeClr val="lt1"/>
+          </a:fontRef>
+        </p:style>
+        <p:txBody>
+          <a:bodyPr rtlCol="0" anchor="ctr"/>
+          <a:lstStyle/>
+          <a:p>
+            <a:pPr algn="ctr"/>
+          </a:p>
+        </p:txBody>
+      </p:sp>
+      <p:sp>
+        <p:nvSpPr>
+          <p:cNvPr id="26" name="Oval 25"/>
+          <p:cNvSpPr/>
+          <p:nvPr/>
+        </p:nvSpPr>
+        <p:spPr>
+          <a:xfrm>
+            <a:off x="603504" y="4572000"/>
+            <a:ext cx="201168" cy="201168"/>
+          </a:xfrm>
+          <a:prstGeom prst="ellipse">
+            <a:avLst/>
+          </a:prstGeom>
+          <a:solidFill>
+            <a:schemeClr val="accent1"/>
+          </a:solidFill>
+          <a:ln>
+            <a:noFill/>
+          </a:ln>
+          <a:effectLst/>
+        </p:spPr>
+        <p:style>
+          <a:lnRef idx="1">
+            <a:schemeClr val="accent1"/>
+          </a:lnRef>
+          <a:fillRef idx="3">
+            <a:schemeClr val="accent1"/>
+          </a:fillRef>
+          <a:effectRef idx="2">
+            <a:schemeClr val="accent1"/>
+          </a:effectRef>
+          <a:fontRef idx="minor">
+            <a:schemeClr val="lt1"/>
+          </a:fontRef>
+        </p:style>
+        <p:txBody>
+          <a:bodyPr rtlCol="0" anchor="ctr"/>
+          <a:lstStyle/>
+          <a:p>
+            <a:pPr algn="ctr"/>
+          </a:p>
+        </p:txBody>
+      </p:sp>
+      <p:sp>
+        <p:nvSpPr>
+          <p:cNvPr id="27" name="TextBox 26"/>
+          <p:cNvSpPr txBox="1"/>
+          <p:nvPr/>
+        </p:nvSpPr>
+        <p:spPr>
+          <a:xfrm>
+            <a:off x="896112" y="4517136"/>
+            <a:ext cx="2103120" cy="310896"/>
+          </a:xfrm>
+          <a:prstGeom prst="rect">
+            <a:avLst/>
+          </a:prstGeom>
+          <a:noFill/>
+        </p:spPr>
+        <p:txBody>
+          <a:bodyPr wrap="square" lIns="0" rIns="0" tIns="0" bIns="0" anchor="t">
+            <a:spAutoFit/>
+          </a:bodyPr>
+          <a:lstStyle/>
+          <a:p>
+            <a:pPr algn="l">
+              <a:spcAft>
+                <a:spcPts val="400"/>
+              </a:spcAft>
+            </a:pPr>
+            <a:r>
+              <a:rPr sz="1300" b="1" i="0">
+                <a:solidFill>
+                  <a:schemeClr val="tx1"/>
+                </a:solidFill>
+              </a:rPr>
+              <a:t>What we gain</a:t>
+            </a:r>
+          </a:p>
+        </p:txBody>
+      </p:sp>
+      <p:sp>
+        <p:nvSpPr>
+          <p:cNvPr id="28" name="TextBox 27"/>
+          <p:cNvSpPr txBox="1"/>
+          <p:nvPr/>
+        </p:nvSpPr>
+        <p:spPr>
+          <a:xfrm>
+            <a:off x="621792" y="4864608"/>
+            <a:ext cx="2377440" cy="1234440"/>
+          </a:xfrm>
+          <a:prstGeom prst="rect">
+            <a:avLst/>
+          </a:prstGeom>
+          <a:noFill/>
+        </p:spPr>
+        <p:txBody>
+          <a:bodyPr wrap="square" lIns="0" rIns="0" tIns="0" bIns="0" anchor="t">
+            <a:spAutoFit/>
+          </a:bodyPr>
+          <a:lstStyle/>
+          <a:p>
+            <a:pPr algn="l" marL="164592" indent="-146304">
+              <a:spcAft>
+                <a:spcPts val="200"/>
+              </a:spcAft>
+              <a:buChar char="•"/>
+            </a:pPr>
+            <a:r>
+              <a:rPr sz="1050" b="0" i="0">
+                <a:solidFill>
+                  <a:schemeClr val="tx1"/>
+                </a:solidFill>
+              </a:rPr>
+              <a:t>Time on the phone vs the network vs the bank, per tap.</a:t>
+            </a:r>
+          </a:p>
+          <a:p>
+            <a:pPr algn="l" marL="164592" indent="-146304">
+              <a:spcAft>
+                <a:spcPts val="200"/>
+              </a:spcAft>
+              <a:buChar char="•"/>
+            </a:pPr>
+            <a:r>
+              <a:rPr sz="1050" b="0" i="0">
+                <a:solidFill>
+                  <a:schemeClr val="tx1"/>
+                </a:solidFill>
+              </a:rPr>
+              <a:t>Errors and crashes linked to the server trace.</a:t>
+            </a:r>
+          </a:p>
+          <a:p>
+            <a:pPr algn="l" marL="164592" indent="-146304">
+              <a:spcAft>
+                <a:spcPts val="200"/>
+              </a:spcAft>
+              <a:buChar char="•"/>
+            </a:pPr>
+            <a:r>
+              <a:rPr sz="1050" b="0" i="0">
+                <a:solidFill>
+                  <a:schemeClr val="tx1"/>
+                </a:solidFill>
+              </a:rPr>
+              <a:t>Breakdown by app version, OS and network type.</a:t>
+            </a:r>
+          </a:p>
+        </p:txBody>
+      </p:sp>
+      <p:sp>
+        <p:nvSpPr>
+          <p:cNvPr id="29" name="Rounded Rectangle 28"/>
+          <p:cNvSpPr/>
+          <p:nvPr/>
+        </p:nvSpPr>
+        <p:spPr>
+          <a:xfrm>
+            <a:off x="3291840" y="4434840"/>
+            <a:ext cx="2651760" cy="1691640"/>
+          </a:xfrm>
+          <a:prstGeom prst="roundRect">
+            <a:avLst>
+              <a:gd name="adj" fmla="val 8000"/>
+            </a:avLst>
+          </a:prstGeom>
+          <a:solidFill>
+            <a:schemeClr val="bg2"/>
+          </a:solidFill>
+          <a:ln>
+            <a:noFill/>
+          </a:ln>
+          <a:effectLst/>
+        </p:spPr>
+        <p:style>
+          <a:lnRef idx="1">
+            <a:schemeClr val="accent1"/>
+          </a:lnRef>
+          <a:fillRef idx="3">
+            <a:schemeClr val="accent1"/>
+          </a:fillRef>
+          <a:effectRef idx="2">
+            <a:schemeClr val="accent1"/>
+          </a:effectRef>
+          <a:fontRef idx="minor">
+            <a:schemeClr val="lt1"/>
+          </a:fontRef>
+        </p:style>
+        <p:txBody>
+          <a:bodyPr rtlCol="0" anchor="ctr"/>
+          <a:lstStyle/>
+          <a:p>
+            <a:pPr algn="ctr"/>
+          </a:p>
+        </p:txBody>
+      </p:sp>
+      <p:sp>
+        <p:nvSpPr>
+          <p:cNvPr id="30" name="Oval 29"/>
+          <p:cNvSpPr/>
+          <p:nvPr/>
+        </p:nvSpPr>
+        <p:spPr>
+          <a:xfrm>
+            <a:off x="3438144" y="4572000"/>
+            <a:ext cx="201168" cy="201168"/>
+          </a:xfrm>
+          <a:prstGeom prst="ellipse">
+            <a:avLst/>
+          </a:prstGeom>
+          <a:solidFill>
+            <a:schemeClr val="accent2"/>
+          </a:solidFill>
+          <a:ln>
+            <a:noFill/>
+          </a:ln>
+          <a:effectLst/>
+        </p:spPr>
+        <p:style>
+          <a:lnRef idx="1">
+            <a:schemeClr val="accent1"/>
+          </a:lnRef>
+          <a:fillRef idx="3">
+            <a:schemeClr val="accent1"/>
+          </a:fillRef>
+          <a:effectRef idx="2">
+            <a:schemeClr val="accent1"/>
+          </a:effectRef>
+          <a:fontRef idx="minor">
+            <a:schemeClr val="lt1"/>
+          </a:fontRef>
+        </p:style>
+        <p:txBody>
+          <a:bodyPr rtlCol="0" anchor="ctr"/>
+          <a:lstStyle/>
+          <a:p>
+            <a:pPr algn="ctr"/>
+          </a:p>
+        </p:txBody>
+      </p:sp>
+      <p:sp>
+        <p:nvSpPr>
+          <p:cNvPr id="31" name="TextBox 30"/>
+          <p:cNvSpPr txBox="1"/>
+          <p:nvPr/>
+        </p:nvSpPr>
+        <p:spPr>
+          <a:xfrm>
+            <a:off x="3730752" y="4517136"/>
+            <a:ext cx="2103120" cy="310896"/>
+          </a:xfrm>
+          <a:prstGeom prst="rect">
+            <a:avLst/>
+          </a:prstGeom>
+          <a:noFill/>
+        </p:spPr>
+        <p:txBody>
+          <a:bodyPr wrap="square" lIns="0" rIns="0" tIns="0" bIns="0" anchor="t">
+            <a:spAutoFit/>
+          </a:bodyPr>
+          <a:lstStyle/>
+          <a:p>
+            <a:pPr algn="l">
+              <a:spcAft>
+                <a:spcPts val="400"/>
+              </a:spcAft>
+            </a:pPr>
+            <a:r>
+              <a:rPr sz="1300" b="1" i="0">
+                <a:solidFill>
+                  <a:schemeClr val="tx1"/>
+                </a:solidFill>
+              </a:rPr>
+              <a:t>What to build</a:t>
+            </a:r>
+          </a:p>
+        </p:txBody>
+      </p:sp>
+      <p:sp>
+        <p:nvSpPr>
+          <p:cNvPr id="32" name="TextBox 31"/>
+          <p:cNvSpPr txBox="1"/>
+          <p:nvPr/>
+        </p:nvSpPr>
+        <p:spPr>
+          <a:xfrm>
+            <a:off x="3456432" y="4864608"/>
+            <a:ext cx="2377440" cy="1234440"/>
+          </a:xfrm>
+          <a:prstGeom prst="rect">
+            <a:avLst/>
+          </a:prstGeom>
+          <a:noFill/>
+        </p:spPr>
+        <p:txBody>
+          <a:bodyPr wrap="square" lIns="0" rIns="0" tIns="0" bIns="0" anchor="t">
+            <a:spAutoFit/>
+          </a:bodyPr>
+          <a:lstStyle/>
+          <a:p>
+            <a:pPr algn="l" marL="164592" indent="-146304">
+              <a:spcAft>
+                <a:spcPts val="200"/>
+              </a:spcAft>
+              <a:buChar char="•"/>
+            </a:pPr>
+            <a:r>
+              <a:rPr sz="1050" b="0" i="0">
+                <a:solidFill>
+                  <a:schemeClr val="tx1"/>
+                </a:solidFill>
+              </a:rPr>
+              <a:t>OTel SDK in the app (auto-instruments the HTTP client).</a:t>
+            </a:r>
+          </a:p>
+          <a:p>
+            <a:pPr algn="l" marL="164592" indent="-146304">
+              <a:spcAft>
+                <a:spcPts val="200"/>
+              </a:spcAft>
+              <a:buChar char="•"/>
+            </a:pPr>
+            <a:r>
+              <a:rPr sz="1050" b="0" i="0">
+                <a:solidFill>
+                  <a:schemeClr val="tx1"/>
+                </a:solidFill>
+              </a:rPr>
+              <a:t>traceparent on the edge allow-list.</a:t>
+            </a:r>
+          </a:p>
+          <a:p>
+            <a:pPr algn="l" marL="164592" indent="-146304">
+              <a:spcAft>
+                <a:spcPts val="200"/>
+              </a:spcAft>
+              <a:buChar char="•"/>
+            </a:pPr>
+            <a:r>
+              <a:rPr sz="1050" b="0" i="0">
+                <a:solidFill>
+                  <a:schemeClr val="tx1"/>
+                </a:solidFill>
+              </a:rPr>
+              <a:t>Public OTLP endpoint + edge collector.</a:t>
+            </a:r>
+          </a:p>
+        </p:txBody>
+      </p:sp>
+      <p:sp>
+        <p:nvSpPr>
+          <p:cNvPr id="33" name="Rounded Rectangle 32"/>
+          <p:cNvSpPr/>
+          <p:nvPr/>
+        </p:nvSpPr>
+        <p:spPr>
+          <a:xfrm>
+            <a:off x="6126480" y="4434840"/>
+            <a:ext cx="2651760" cy="1691640"/>
+          </a:xfrm>
+          <a:prstGeom prst="roundRect">
+            <a:avLst>
+              <a:gd name="adj" fmla="val 8000"/>
+            </a:avLst>
+          </a:prstGeom>
+          <a:solidFill>
+            <a:schemeClr val="bg2"/>
+          </a:solidFill>
+          <a:ln>
+            <a:noFill/>
+          </a:ln>
+          <a:effectLst/>
+        </p:spPr>
+        <p:style>
+          <a:lnRef idx="1">
+            <a:schemeClr val="accent1"/>
+          </a:lnRef>
+          <a:fillRef idx="3">
+            <a:schemeClr val="accent1"/>
+          </a:fillRef>
+          <a:effectRef idx="2">
+            <a:schemeClr val="accent1"/>
+          </a:effectRef>
+          <a:fontRef idx="minor">
+            <a:schemeClr val="lt1"/>
+          </a:fontRef>
+        </p:style>
+        <p:txBody>
+          <a:bodyPr rtlCol="0" anchor="ctr"/>
+          <a:lstStyle/>
+          <a:p>
+            <a:pPr algn="ctr"/>
+          </a:p>
+        </p:txBody>
+      </p:sp>
+      <p:sp>
+        <p:nvSpPr>
+          <p:cNvPr id="34" name="Oval 33"/>
+          <p:cNvSpPr/>
+          <p:nvPr/>
+        </p:nvSpPr>
+        <p:spPr>
+          <a:xfrm>
+            <a:off x="6272784" y="4572000"/>
+            <a:ext cx="201168" cy="201168"/>
+          </a:xfrm>
+          <a:prstGeom prst="ellipse">
+            <a:avLst/>
+          </a:prstGeom>
+          <a:solidFill>
+            <a:schemeClr val="accent3"/>
+          </a:solidFill>
+          <a:ln>
+            <a:noFill/>
+          </a:ln>
+          <a:effectLst/>
+        </p:spPr>
+        <p:style>
+          <a:lnRef idx="1">
+            <a:schemeClr val="accent1"/>
+          </a:lnRef>
+          <a:fillRef idx="3">
+            <a:schemeClr val="accent1"/>
+          </a:fillRef>
+          <a:effectRef idx="2">
+            <a:schemeClr val="accent1"/>
+          </a:effectRef>
+          <a:fontRef idx="minor">
+            <a:schemeClr val="lt1"/>
+          </a:fontRef>
+        </p:style>
+        <p:txBody>
+          <a:bodyPr rtlCol="0" anchor="ctr"/>
+          <a:lstStyle/>
+          <a:p>
+            <a:pPr algn="ctr"/>
+          </a:p>
+        </p:txBody>
+      </p:sp>
+      <p:sp>
+        <p:nvSpPr>
+          <p:cNvPr id="35" name="TextBox 34"/>
+          <p:cNvSpPr txBox="1"/>
+          <p:nvPr/>
+        </p:nvSpPr>
+        <p:spPr>
+          <a:xfrm>
+            <a:off x="6565392" y="4517136"/>
+            <a:ext cx="2103120" cy="310896"/>
+          </a:xfrm>
+          <a:prstGeom prst="rect">
+            <a:avLst/>
+          </a:prstGeom>
+          <a:noFill/>
+        </p:spPr>
+        <p:txBody>
+          <a:bodyPr wrap="square" lIns="0" rIns="0" tIns="0" bIns="0" anchor="t">
+            <a:spAutoFit/>
+          </a:bodyPr>
+          <a:lstStyle/>
+          <a:p>
+            <a:pPr algn="l">
+              <a:spcAft>
+                <a:spcPts val="400"/>
+              </a:spcAft>
+            </a:pPr>
+            <a:r>
+              <a:rPr sz="1300" b="1" i="0">
+                <a:solidFill>
+                  <a:schemeClr val="tx1"/>
+                </a:solidFill>
+              </a:rPr>
+              <a:t>Guardrails</a:t>
+            </a:r>
+          </a:p>
+        </p:txBody>
+      </p:sp>
+      <p:sp>
+        <p:nvSpPr>
+          <p:cNvPr id="36" name="TextBox 35"/>
+          <p:cNvSpPr txBox="1"/>
+          <p:nvPr/>
+        </p:nvSpPr>
+        <p:spPr>
+          <a:xfrm>
+            <a:off x="6291072" y="4864608"/>
+            <a:ext cx="2377440" cy="1234440"/>
+          </a:xfrm>
+          <a:prstGeom prst="rect">
+            <a:avLst/>
+          </a:prstGeom>
+          <a:noFill/>
+        </p:spPr>
+        <p:txBody>
+          <a:bodyPr wrap="square" lIns="0" rIns="0" tIns="0" bIns="0" anchor="t">
+            <a:spAutoFit/>
+          </a:bodyPr>
+          <a:lstStyle/>
+          <a:p>
+            <a:pPr algn="l" marL="164592" indent="-146304">
+              <a:spcAft>
+                <a:spcPts val="200"/>
+              </a:spcAft>
+              <a:buChar char="•"/>
+            </a:pPr>
+            <a:r>
+              <a:rPr sz="1050" b="0" i="0">
+                <a:solidFill>
+                  <a:schemeClr val="tx1"/>
+                </a:solidFill>
+              </a:rPr>
+              <a:t>No account numbers, names or device IDs in spans.</a:t>
+            </a:r>
+          </a:p>
+          <a:p>
+            <a:pPr algn="l" marL="164592" indent="-146304">
+              <a:spcAft>
+                <a:spcPts val="200"/>
+              </a:spcAft>
+              <a:buChar char="•"/>
+            </a:pPr>
+            <a:r>
+              <a:rPr sz="1050" b="0" i="0">
+                <a:solidFill>
+                  <a:schemeClr val="tx1"/>
+                </a:solidFill>
+              </a:rPr>
+              <a:t>Collector redaction + attribute allow-list.</a:t>
+            </a:r>
+          </a:p>
+          <a:p>
+            <a:pPr algn="l" marL="164592" indent="-146304">
+              <a:spcAft>
+                <a:spcPts val="200"/>
+              </a:spcAft>
+              <a:buChar char="•"/>
+            </a:pPr>
+            <a:r>
+              <a:rPr sz="1050" b="0" i="0">
+                <a:solidFill>
+                  <a:schemeClr val="tx1"/>
+                </a:solidFill>
+              </a:rPr>
+              <a:t>Journey set by the gateway, never by the app.</a:t>
+            </a:r>
+          </a:p>
+        </p:txBody>
+      </p:sp>
+      <p:sp>
+        <p:nvSpPr>
+          <p:cNvPr id="37" name="Rounded Rectangle 36"/>
+          <p:cNvSpPr/>
+          <p:nvPr/>
+        </p:nvSpPr>
+        <p:spPr>
+          <a:xfrm>
+            <a:off x="8961120" y="4434840"/>
+            <a:ext cx="2651760" cy="1691640"/>
+          </a:xfrm>
+          <a:prstGeom prst="roundRect">
+            <a:avLst>
+              <a:gd name="adj" fmla="val 8000"/>
+            </a:avLst>
+          </a:prstGeom>
+          <a:solidFill>
+            <a:schemeClr val="bg2"/>
+          </a:solidFill>
+          <a:ln>
+            <a:noFill/>
+          </a:ln>
+          <a:effectLst/>
+        </p:spPr>
+        <p:style>
+          <a:lnRef idx="1">
+            <a:schemeClr val="accent1"/>
+          </a:lnRef>
+          <a:fillRef idx="3">
+            <a:schemeClr val="accent1"/>
+          </a:fillRef>
+          <a:effectRef idx="2">
+            <a:schemeClr val="accent1"/>
+          </a:effectRef>
+          <a:fontRef idx="minor">
+            <a:schemeClr val="lt1"/>
+          </a:fontRef>
+        </p:style>
+        <p:txBody>
+          <a:bodyPr rtlCol="0" anchor="ctr"/>
+          <a:lstStyle/>
+          <a:p>
+            <a:pPr algn="ctr"/>
+          </a:p>
+        </p:txBody>
+      </p:sp>
+      <p:sp>
+        <p:nvSpPr>
+          <p:cNvPr id="38" name="Oval 37"/>
+          <p:cNvSpPr/>
+          <p:nvPr/>
+        </p:nvSpPr>
+        <p:spPr>
+          <a:xfrm>
+            <a:off x="9107424" y="4572000"/>
+            <a:ext cx="201168" cy="201168"/>
+          </a:xfrm>
+          <a:prstGeom prst="ellipse">
+            <a:avLst/>
+          </a:prstGeom>
+          <a:solidFill>
+            <a:schemeClr val="accent4"/>
+          </a:solidFill>
+          <a:ln>
+            <a:noFill/>
+          </a:ln>
+          <a:effectLst/>
+        </p:spPr>
+        <p:style>
+          <a:lnRef idx="1">
+            <a:schemeClr val="accent1"/>
+          </a:lnRef>
+          <a:fillRef idx="3">
+            <a:schemeClr val="accent1"/>
+          </a:fillRef>
+          <a:effectRef idx="2">
+            <a:schemeClr val="accent1"/>
+          </a:effectRef>
+          <a:fontRef idx="minor">
+            <a:schemeClr val="lt1"/>
+          </a:fontRef>
+        </p:style>
+        <p:txBody>
+          <a:bodyPr rtlCol="0" anchor="ctr"/>
+          <a:lstStyle/>
+          <a:p>
+            <a:pPr algn="ctr"/>
+          </a:p>
+        </p:txBody>
+      </p:sp>
+      <p:sp>
+        <p:nvSpPr>
+          <p:cNvPr id="39" name="TextBox 38"/>
+          <p:cNvSpPr txBox="1"/>
+          <p:nvPr/>
+        </p:nvSpPr>
+        <p:spPr>
+          <a:xfrm>
+            <a:off x="9400032" y="4517136"/>
+            <a:ext cx="2103120" cy="310896"/>
+          </a:xfrm>
+          <a:prstGeom prst="rect">
+            <a:avLst/>
+          </a:prstGeom>
+          <a:noFill/>
+        </p:spPr>
+        <p:txBody>
+          <a:bodyPr wrap="square" lIns="0" rIns="0" tIns="0" bIns="0" anchor="t">
+            <a:spAutoFit/>
+          </a:bodyPr>
+          <a:lstStyle/>
+          <a:p>
+            <a:pPr algn="l">
+              <a:spcAft>
+                <a:spcPts val="400"/>
+              </a:spcAft>
+            </a:pPr>
+            <a:r>
+              <a:rPr sz="1300" b="1" i="0">
+                <a:solidFill>
+                  <a:schemeClr val="tx1"/>
+                </a:solidFill>
+              </a:rPr>
+              <a:t>Decide</a:t>
+            </a:r>
+          </a:p>
+        </p:txBody>
+      </p:sp>
+      <p:sp>
+        <p:nvSpPr>
+          <p:cNvPr id="40" name="TextBox 39"/>
+          <p:cNvSpPr txBox="1"/>
+          <p:nvPr/>
+        </p:nvSpPr>
+        <p:spPr>
+          <a:xfrm>
+            <a:off x="9125712" y="4864608"/>
+            <a:ext cx="2377440" cy="1234440"/>
+          </a:xfrm>
+          <a:prstGeom prst="rect">
+            <a:avLst/>
+          </a:prstGeom>
+          <a:noFill/>
+        </p:spPr>
+        <p:txBody>
+          <a:bodyPr wrap="square" lIns="0" rIns="0" tIns="0" bIns="0" anchor="t">
+            <a:spAutoFit/>
+          </a:bodyPr>
+          <a:lstStyle/>
+          <a:p>
+            <a:pPr algn="l" marL="164592" indent="-146304">
+              <a:spcAft>
+                <a:spcPts val="200"/>
+              </a:spcAft>
+              <a:buChar char="•"/>
+            </a:pPr>
+            <a:r>
+              <a:rPr sz="1050" b="0" i="0">
+                <a:solidFill>
+                  <a:schemeClr val="tx1"/>
+                </a:solidFill>
+              </a:rPr>
+              <a:t>Trust client trace IDs, or start a new trace at the gateway?</a:t>
+            </a:r>
+          </a:p>
+          <a:p>
+            <a:pPr algn="l" marL="164592" indent="-146304">
+              <a:spcAft>
+                <a:spcPts val="200"/>
+              </a:spcAft>
+              <a:buChar char="•"/>
+            </a:pPr>
+            <a:r>
+              <a:rPr sz="1050" b="0" i="0">
+                <a:solidFill>
+                  <a:schemeClr val="tx1"/>
+                </a:solidFill>
+              </a:rPr>
+              <a:t>OpenTelemetry SDK or a commercial RUM product?</a:t>
+            </a:r>
+          </a:p>
+          <a:p>
+            <a:pPr algn="l" marL="164592" indent="-146304">
+              <a:spcAft>
+                <a:spcPts val="200"/>
+              </a:spcAft>
+              <a:buChar char="•"/>
+            </a:pPr>
+            <a:r>
+              <a:rPr sz="1050" b="0" i="0">
+                <a:solidFill>
+                  <a:schemeClr val="tx1"/>
+                </a:solidFill>
+              </a:rPr>
+              <a:t>Consent and sampling rate per app release.</a:t>
+            </a:r>
+          </a:p>
+        </p:txBody>
+      </p:sp>
+    </p:spTree>
+  </p:cSld>
+  <p:clrMapOvr>
+    <a:masterClrMapping/>
+  </p:clrMapOvr>
+</p:sld>
+</file>
+
+<file path=ppt/slides/slide25.xml><?xml version="1.0" encoding="utf-8"?>
 <p:sld xmlns:a="http://schemas.openxmlformats.org/drawingml/2006/main" xmlns:r="http://schemas.openxmlformats.org/officeDocument/2006/relationships" xmlns:p="http://schemas.openxmlformats.org/presentationml/2006/main">
   <p:cSld name="Slide 6">
     <p:spTree>
@@ -25204,7 +27297,7 @@
 </p:sld>
 </file>
 
-<file path=ppt/slides/slide25.xml><?xml version="1.0" encoding="utf-8"?>
+<file path=ppt/slides/slide26.xml><?xml version="1.0" encoding="utf-8"?>
 <p:sld xmlns:a="http://schemas.openxmlformats.org/drawingml/2006/main" xmlns:r="http://schemas.openxmlformats.org/officeDocument/2006/relationships" xmlns:p="http://schemas.openxmlformats.org/presentationml/2006/main">
   <p:cSld name="Slide 7">
     <p:spTree>

</xml_diff>